<commit_message>
Update years of experience to 5+
</commit_message>
<xml_diff>
--- a/Tracey-Scott-Portfolio.pptx
+++ b/Tracey-Scott-Portfolio.pptx
@@ -2616,7 +2616,7 @@
                 <a:ea typeface="Calibri" pitchFamily="34" charset="-122"/>
                 <a:cs typeface="Calibri" pitchFamily="34" charset="-120"/>
               </a:rPr>
-              <a:t>Cybersecurity-focused IT leader with 4+ years building and securing enterprise cloud and hybrid infrastructure in fast-paced startup environments.</a:t>
+              <a:t>Cybersecurity-focused IT leader with 5+ years building and securing enterprise cloud and hybrid infrastructure in fast-paced startup environments.</a:t>
             </a:r>
             <a:endParaRPr lang="en-US" sz="1500" dirty="0"/>
           </a:p>
@@ -2732,7 +2732,7 @@
                 <a:ea typeface="Georgia" pitchFamily="34" charset="-122"/>
                 <a:cs typeface="Georgia" pitchFamily="34" charset="-120"/>
               </a:rPr>
-              <a:t>4+</a:t>
+              <a:t>5+</a:t>
             </a:r>
             <a:endParaRPr lang="en-US" sz="4800" dirty="0"/>
           </a:p>

</xml_diff>

<commit_message>
Apply Carbon Gold palette
</commit_message>
<xml_diff>
--- a/Tracey-Scott-Portfolio.pptx
+++ b/Tracey-Scott-Portfolio.pptx
@@ -128,7 +128,7 @@
             <a:pPr>
               <a:defRPr sz="1400" b="0" i="0" u="none" strike="noStrike">
                 <a:solidFill>
-                  <a:srgbClr val="1E2761"/>
+                  <a:srgbClr val="111111"/>
                 </a:solidFill>
                 <a:latin typeface="Arial"/>
               </a:defRPr>
@@ -136,7 +136,7 @@
             <a:r>
               <a:rPr sz="1400" b="0" i="0" u="none" strike="noStrike">
                 <a:solidFill>
-                  <a:srgbClr val="1E2761"/>
+                  <a:srgbClr val="111111"/>
                 </a:solidFill>
                 <a:latin typeface="Arial"/>
               </a:rPr>
@@ -169,11 +169,11 @@
           </c:tx>
           <c:spPr>
             <a:solidFill>
-              <a:srgbClr val="F59E0B"/>
+              <a:srgbClr val="D4AF37"/>
             </a:solidFill>
             <a:ln w="38100" cap="flat">
               <a:solidFill>
-                <a:srgbClr val="F59E0B"/>
+                <a:srgbClr val="D4AF37"/>
               </a:solidFill>
               <a:prstDash val="solid"/>
               <a:round/>
@@ -190,7 +190,7 @@
                 <a:pPr>
                   <a:defRPr b="0" i="0" strike="noStrike" sz="1200" u="none">
                     <a:solidFill>
-                      <a:srgbClr val="0F172A"/>
+                      <a:srgbClr val="0A0A0A"/>
                     </a:solidFill>
                     <a:latin typeface="Arial"/>
                   </a:defRPr>
@@ -210,11 +210,11 @@
             <c:size val="6"/>
             <c:spPr>
               <a:solidFill>
-                <a:srgbClr val="F59E0B"/>
+                <a:srgbClr val="D4AF37"/>
               </a:solidFill>
               <a:ln w="9525" cap="flat">
                 <a:solidFill>
-                  <a:srgbClr val="F59E0B"/>
+                  <a:srgbClr val="D4AF37"/>
                 </a:solidFill>
                 <a:prstDash val="solid"/>
                 <a:round/>
@@ -288,7 +288,7 @@
               <a:pPr>
                 <a:defRPr b="0" i="0" strike="noStrike" sz="1200" u="none">
                   <a:solidFill>
-                    <a:srgbClr val="0F172A"/>
+                    <a:srgbClr val="0A0A0A"/>
                   </a:solidFill>
                   <a:latin typeface="Arial"/>
                 </a:defRPr>
@@ -335,7 +335,7 @@
             <a:pPr>
               <a:defRPr sz="1200" b="0" i="0" u="none" strike="noStrike">
                 <a:solidFill>
-                  <a:srgbClr val="64748B"/>
+                  <a:srgbClr val="9CA3AF"/>
                 </a:solidFill>
                 <a:latin typeface="Arial"/>
               </a:defRPr>
@@ -387,7 +387,7 @@
             <a:pPr>
               <a:defRPr sz="1200" b="0" i="0" u="none" strike="noStrike">
                 <a:solidFill>
-                  <a:srgbClr val="64748B"/>
+                  <a:srgbClr val="9CA3AF"/>
                 </a:solidFill>
                 <a:latin typeface="Arial"/>
               </a:defRPr>
@@ -439,7 +439,7 @@
             <a:pPr>
               <a:defRPr sz="1400" b="0" i="0" u="none" strike="noStrike">
                 <a:solidFill>
-                  <a:srgbClr val="1E2761"/>
+                  <a:srgbClr val="111111"/>
                 </a:solidFill>
                 <a:latin typeface="Arial"/>
               </a:defRPr>
@@ -447,7 +447,7 @@
             <a:r>
               <a:rPr sz="1400" b="0" i="0" u="none" strike="noStrike">
                 <a:solidFill>
-                  <a:srgbClr val="1E2761"/>
+                  <a:srgbClr val="111111"/>
                 </a:solidFill>
                 <a:latin typeface="Arial"/>
               </a:rPr>
@@ -496,7 +496,7 @@
             <c:bubble3D val="0"/>
             <c:spPr>
               <a:solidFill>
-                <a:srgbClr val="1E2761"/>
+                <a:srgbClr val="111111"/>
               </a:solidFill>
               <a:effectLst/>
             </c:spPr>
@@ -506,7 +506,7 @@
             <c:bubble3D val="0"/>
             <c:spPr>
               <a:solidFill>
-                <a:srgbClr val="CADCFC"/>
+                <a:srgbClr val="E5E7EB"/>
               </a:solidFill>
               <a:effectLst/>
             </c:spPr>
@@ -523,7 +523,7 @@
                   <a:pPr>
                     <a:defRPr sz="1200" b="0" i="0" u="none" strike="noStrike">
                       <a:solidFill>
-                        <a:srgbClr val="FFFFFF"/>
+                        <a:srgbClr val="F5F5F5"/>
                       </a:solidFill>
                       <a:latin typeface="Arial"/>
                     </a:defRPr>
@@ -548,7 +548,7 @@
                   <a:pPr>
                     <a:defRPr sz="1200" b="0" i="0" u="none" strike="noStrike">
                       <a:solidFill>
-                        <a:srgbClr val="FFFFFF"/>
+                        <a:srgbClr val="F5F5F5"/>
                       </a:solidFill>
                       <a:latin typeface="Arial"/>
                     </a:defRPr>
@@ -669,7 +669,7 @@
           </c:tx>
           <c:spPr>
             <a:solidFill>
-              <a:srgbClr val="1E2761"/>
+              <a:srgbClr val="111111"/>
             </a:solidFill>
             <a:effectLst/>
           </c:spPr>
@@ -683,7 +683,7 @@
                 <a:pPr>
                   <a:defRPr b="0" i="0" strike="noStrike" sz="1200" u="none">
                     <a:solidFill>
-                      <a:srgbClr val="0F172A"/>
+                      <a:srgbClr val="0A0A0A"/>
                     </a:solidFill>
                     <a:latin typeface="Arial"/>
                   </a:defRPr>
@@ -775,7 +775,7 @@
               <a:pPr>
                 <a:defRPr b="0" i="0" strike="noStrike" sz="1200" u="none">
                   <a:solidFill>
-                    <a:srgbClr val="0F172A"/>
+                    <a:srgbClr val="0A0A0A"/>
                   </a:solidFill>
                   <a:latin typeface="Arial"/>
                 </a:defRPr>
@@ -823,7 +823,7 @@
             <a:pPr>
               <a:defRPr sz="1300" b="0" i="0" u="none" strike="noStrike">
                 <a:solidFill>
-                  <a:srgbClr val="0F172A"/>
+                  <a:srgbClr val="0A0A0A"/>
                 </a:solidFill>
                 <a:latin typeface="Arial"/>
               </a:defRPr>
@@ -877,7 +877,7 @@
             <a:pPr>
               <a:defRPr sz="1200" b="0" i="0" u="none" strike="noStrike">
                 <a:solidFill>
-                  <a:srgbClr val="64748B"/>
+                  <a:srgbClr val="9CA3AF"/>
                 </a:solidFill>
                 <a:latin typeface="Arial"/>
               </a:defRPr>
@@ -2281,7 +2281,7 @@
     <p:bg>
       <p:bgPr>
         <a:solidFill>
-          <a:srgbClr val="1E2761"/>
+          <a:srgbClr val="111111"/>
         </a:solidFill>
       </p:bgPr>
     </p:bg>
@@ -2314,7 +2314,7 @@
             <a:avLst/>
           </a:prstGeom>
           <a:solidFill>
-            <a:srgbClr val="F59E0B"/>
+            <a:srgbClr val="D4AF37"/>
           </a:solidFill>
           <a:ln/>
         </p:spPr>
@@ -2346,7 +2346,7 @@
             <a:r>
               <a:rPr lang="en-US" sz="6000" b="1" spc="200" kern="0" dirty="0">
                 <a:solidFill>
-                  <a:srgbClr val="FFFFFF"/>
+                  <a:srgbClr val="F5F5F5"/>
                 </a:solidFill>
                 <a:latin typeface="Georgia" pitchFamily="34" charset="0"/>
                 <a:ea typeface="Georgia" pitchFamily="34" charset="-122"/>
@@ -2385,7 +2385,7 @@
             <a:r>
               <a:rPr lang="en-US" sz="2200" dirty="0">
                 <a:solidFill>
-                  <a:srgbClr val="CADCFC"/>
+                  <a:srgbClr val="E5E7EB"/>
                 </a:solidFill>
                 <a:latin typeface="Calibri" pitchFamily="34" charset="0"/>
                 <a:ea typeface="Calibri" pitchFamily="34" charset="-122"/>
@@ -2412,7 +2412,7 @@
             <a:avLst/>
           </a:prstGeom>
           <a:solidFill>
-            <a:srgbClr val="F59E0B"/>
+            <a:srgbClr val="D4AF37"/>
           </a:solidFill>
           <a:ln/>
         </p:spPr>
@@ -2444,7 +2444,7 @@
             <a:r>
               <a:rPr lang="en-US" sz="1600" dirty="0">
                 <a:solidFill>
-                  <a:srgbClr val="FFFFFF"/>
+                  <a:srgbClr val="F5F5F5"/>
                 </a:solidFill>
               </a:rPr>
               <a:t>IT Operations Manager &amp; Business Analyst  |  Greenville, SC</a:t>
@@ -2480,7 +2480,7 @@
             <a:r>
               <a:rPr lang="en-US" sz="1400" i="1" dirty="0">
                 <a:solidFill>
-                  <a:srgbClr val="F59E0B"/>
+                  <a:srgbClr val="D4AF37"/>
                 </a:solidFill>
               </a:rPr>
               <a:t>Portfolio Deck  •  2026</a:t>
@@ -2503,7 +2503,7 @@
     <p:bg>
       <p:bgPr>
         <a:solidFill>
-          <a:srgbClr val="FFFFFF"/>
+          <a:srgbClr val="F5F5F5"/>
         </a:solidFill>
       </p:bgPr>
     </p:bg>
@@ -2548,7 +2548,7 @@
             <a:r>
               <a:rPr lang="en-US" sz="4000" b="1" dirty="0">
                 <a:solidFill>
-                  <a:srgbClr val="1E2761"/>
+                  <a:srgbClr val="111111"/>
                 </a:solidFill>
                 <a:latin typeface="Georgia" pitchFamily="34" charset="0"/>
                 <a:ea typeface="Georgia" pitchFamily="34" charset="-122"/>
@@ -2575,7 +2575,7 @@
             <a:avLst/>
           </a:prstGeom>
           <a:solidFill>
-            <a:srgbClr val="CADCFC"/>
+            <a:srgbClr val="E5E7EB"/>
           </a:solidFill>
           <a:ln/>
         </p:spPr>
@@ -2610,7 +2610,7 @@
             <a:r>
               <a:rPr lang="en-US" sz="1500" dirty="0">
                 <a:solidFill>
-                  <a:srgbClr val="0F172A"/>
+                  <a:srgbClr val="0A0A0A"/>
                 </a:solidFill>
                 <a:latin typeface="Calibri" pitchFamily="34" charset="0"/>
                 <a:ea typeface="Calibri" pitchFamily="34" charset="-122"/>
@@ -2630,7 +2630,7 @@
             <a:r>
               <a:rPr lang="en-US" sz="1500" dirty="0">
                 <a:solidFill>
-                  <a:srgbClr val="0F172A"/>
+                  <a:srgbClr val="0A0A0A"/>
                 </a:solidFill>
                 <a:latin typeface="Calibri" pitchFamily="34" charset="0"/>
                 <a:ea typeface="Calibri" pitchFamily="34" charset="-122"/>
@@ -2647,7 +2647,7 @@
             <a:r>
               <a:rPr lang="en-US" sz="1500" dirty="0">
                 <a:solidFill>
-                  <a:srgbClr val="0F172A"/>
+                  <a:srgbClr val="0A0A0A"/>
                 </a:solidFill>
                 <a:latin typeface="Calibri" pitchFamily="34" charset="0"/>
                 <a:ea typeface="Calibri" pitchFamily="34" charset="-122"/>
@@ -2674,7 +2674,7 @@
             <a:avLst/>
           </a:prstGeom>
           <a:solidFill>
-            <a:srgbClr val="1E2761"/>
+            <a:srgbClr val="111111"/>
           </a:solidFill>
           <a:ln/>
         </p:spPr>
@@ -2694,7 +2694,7 @@
             <a:avLst/>
           </a:prstGeom>
           <a:solidFill>
-            <a:srgbClr val="F59E0B"/>
+            <a:srgbClr val="D4AF37"/>
           </a:solidFill>
           <a:ln/>
         </p:spPr>
@@ -2726,7 +2726,7 @@
             <a:r>
               <a:rPr lang="en-US" sz="4800" b="1" dirty="0">
                 <a:solidFill>
-                  <a:srgbClr val="FFFFFF"/>
+                  <a:srgbClr val="F5F5F5"/>
                 </a:solidFill>
                 <a:latin typeface="Georgia" pitchFamily="34" charset="0"/>
                 <a:ea typeface="Georgia" pitchFamily="34" charset="-122"/>
@@ -2765,7 +2765,7 @@
             <a:r>
               <a:rPr lang="en-US" sz="1300" dirty="0">
                 <a:solidFill>
-                  <a:srgbClr val="CADCFC"/>
+                  <a:srgbClr val="E5E7EB"/>
                 </a:solidFill>
               </a:rPr>
               <a:t>Years Experience</a:t>
@@ -2789,7 +2789,7 @@
             <a:avLst/>
           </a:prstGeom>
           <a:solidFill>
-            <a:srgbClr val="1E2761"/>
+            <a:srgbClr val="111111"/>
           </a:solidFill>
           <a:ln/>
         </p:spPr>
@@ -2809,7 +2809,7 @@
             <a:avLst/>
           </a:prstGeom>
           <a:solidFill>
-            <a:srgbClr val="F59E0B"/>
+            <a:srgbClr val="D4AF37"/>
           </a:solidFill>
           <a:ln/>
         </p:spPr>
@@ -2841,7 +2841,7 @@
             <a:r>
               <a:rPr lang="en-US" sz="4800" b="1" dirty="0">
                 <a:solidFill>
-                  <a:srgbClr val="FFFFFF"/>
+                  <a:srgbClr val="F5F5F5"/>
                 </a:solidFill>
                 <a:latin typeface="Georgia" pitchFamily="34" charset="0"/>
                 <a:ea typeface="Georgia" pitchFamily="34" charset="-122"/>
@@ -2880,7 +2880,7 @@
             <a:r>
               <a:rPr lang="en-US" sz="1300" dirty="0">
                 <a:solidFill>
-                  <a:srgbClr val="CADCFC"/>
+                  <a:srgbClr val="E5E7EB"/>
                 </a:solidFill>
               </a:rPr>
               <a:t>Months to Full Security Framework</a:t>
@@ -2904,7 +2904,7 @@
             <a:avLst/>
           </a:prstGeom>
           <a:solidFill>
-            <a:srgbClr val="1E2761"/>
+            <a:srgbClr val="111111"/>
           </a:solidFill>
           <a:ln/>
         </p:spPr>
@@ -2924,7 +2924,7 @@
             <a:avLst/>
           </a:prstGeom>
           <a:solidFill>
-            <a:srgbClr val="F59E0B"/>
+            <a:srgbClr val="D4AF37"/>
           </a:solidFill>
           <a:ln/>
         </p:spPr>
@@ -2956,7 +2956,7 @@
             <a:r>
               <a:rPr lang="en-US" sz="4800" b="1" dirty="0">
                 <a:solidFill>
-                  <a:srgbClr val="FFFFFF"/>
+                  <a:srgbClr val="F5F5F5"/>
                 </a:solidFill>
                 <a:latin typeface="Georgia" pitchFamily="34" charset="0"/>
                 <a:ea typeface="Georgia" pitchFamily="34" charset="-122"/>
@@ -2995,7 +2995,7 @@
             <a:r>
               <a:rPr lang="en-US" sz="1300" dirty="0">
                 <a:solidFill>
-                  <a:srgbClr val="CADCFC"/>
+                  <a:srgbClr val="E5E7EB"/>
                 </a:solidFill>
               </a:rPr>
               <a:t>Predictive Model Accuracy</a:t>
@@ -3019,7 +3019,7 @@
             <a:avLst/>
           </a:prstGeom>
           <a:solidFill>
-            <a:srgbClr val="1E2761"/>
+            <a:srgbClr val="111111"/>
           </a:solidFill>
           <a:ln/>
         </p:spPr>
@@ -3039,7 +3039,7 @@
             <a:avLst/>
           </a:prstGeom>
           <a:solidFill>
-            <a:srgbClr val="F59E0B"/>
+            <a:srgbClr val="D4AF37"/>
           </a:solidFill>
           <a:ln/>
         </p:spPr>
@@ -3071,7 +3071,7 @@
             <a:r>
               <a:rPr lang="en-US" sz="4800" b="1" dirty="0">
                 <a:solidFill>
-                  <a:srgbClr val="FFFFFF"/>
+                  <a:srgbClr val="F5F5F5"/>
                 </a:solidFill>
                 <a:latin typeface="Georgia" pitchFamily="34" charset="0"/>
                 <a:ea typeface="Georgia" pitchFamily="34" charset="-122"/>
@@ -3110,7 +3110,7 @@
             <a:r>
               <a:rPr lang="en-US" sz="1300" dirty="0">
                 <a:solidFill>
-                  <a:srgbClr val="CADCFC"/>
+                  <a:srgbClr val="E5E7EB"/>
                 </a:solidFill>
               </a:rPr>
               <a:t>Clouds (AWS • Azure • GCP)</a:t>
@@ -3134,7 +3134,7 @@
             <a:avLst/>
           </a:prstGeom>
           <a:solidFill>
-            <a:srgbClr val="1E2761"/>
+            <a:srgbClr val="111111"/>
           </a:solidFill>
           <a:ln/>
         </p:spPr>
@@ -3166,7 +3166,7 @@
             <a:r>
               <a:rPr lang="en-US" sz="1000" dirty="0">
                 <a:solidFill>
-                  <a:srgbClr val="CADCFC"/>
+                  <a:srgbClr val="E5E7EB"/>
                 </a:solidFill>
               </a:rPr>
               <a:t>Tracey Scott  |  Cybersecurity • Cloud • SOC  |  traceysscott82@gmail.com</a:t>
@@ -3202,7 +3202,7 @@
             <a:r>
               <a:rPr lang="en-US" sz="1000" dirty="0">
                 <a:solidFill>
-                  <a:srgbClr val="CADCFC"/>
+                  <a:srgbClr val="E5E7EB"/>
                 </a:solidFill>
               </a:rPr>
               <a:t>2</a:t>
@@ -3225,7 +3225,7 @@
     <p:bg>
       <p:bgPr>
         <a:solidFill>
-          <a:srgbClr val="FFFFFF"/>
+          <a:srgbClr val="F5F5F5"/>
         </a:solidFill>
       </p:bgPr>
     </p:bg>
@@ -3270,7 +3270,7 @@
             <a:r>
               <a:rPr lang="en-US" sz="3600" b="1" dirty="0">
                 <a:solidFill>
-                  <a:srgbClr val="1E2761"/>
+                  <a:srgbClr val="111111"/>
                 </a:solidFill>
                 <a:latin typeface="Georgia" pitchFamily="34" charset="0"/>
                 <a:ea typeface="Georgia" pitchFamily="34" charset="-122"/>
@@ -3297,11 +3297,11 @@
             <a:avLst/>
           </a:prstGeom>
           <a:solidFill>
-            <a:srgbClr val="FFFFFF"/>
+            <a:srgbClr val="F5F5F5"/>
           </a:solidFill>
           <a:ln w="12700">
             <a:solidFill>
-              <a:srgbClr val="CADCFC"/>
+              <a:srgbClr val="E5E7EB"/>
             </a:solidFill>
             <a:prstDash val="solid"/>
           </a:ln>
@@ -3329,7 +3329,7 @@
             <a:avLst/>
           </a:prstGeom>
           <a:solidFill>
-            <a:srgbClr val="F59E0B"/>
+            <a:srgbClr val="D4AF37"/>
           </a:solidFill>
           <a:ln/>
         </p:spPr>
@@ -3361,7 +3361,7 @@
             <a:r>
               <a:rPr lang="en-US" sz="1800" b="1" dirty="0">
                 <a:solidFill>
-                  <a:srgbClr val="1E2761"/>
+                  <a:srgbClr val="111111"/>
                 </a:solidFill>
                 <a:latin typeface="Georgia" pitchFamily="34" charset="0"/>
                 <a:ea typeface="Georgia" pitchFamily="34" charset="-122"/>
@@ -3401,7 +3401,7 @@
             <a:r>
               <a:rPr lang="en-US" sz="1300" dirty="0">
                 <a:solidFill>
-                  <a:srgbClr val="0F172A"/>
+                  <a:srgbClr val="0A0A0A"/>
                 </a:solidFill>
               </a:rPr>
               <a:t>IDS/IPS &amp; Firewall Admin</a:t>
@@ -3416,7 +3416,7 @@
             <a:r>
               <a:rPr lang="en-US" sz="1300" dirty="0">
                 <a:solidFill>
-                  <a:srgbClr val="0F172A"/>
+                  <a:srgbClr val="0A0A0A"/>
                 </a:solidFill>
               </a:rPr>
               <a:t>Endpoint / EDR &amp; MDM</a:t>
@@ -3431,7 +3431,7 @@
             <a:r>
               <a:rPr lang="en-US" sz="1300" dirty="0">
                 <a:solidFill>
-                  <a:srgbClr val="0F172A"/>
+                  <a:srgbClr val="0A0A0A"/>
                 </a:solidFill>
               </a:rPr>
               <a:t>Incident Response</a:t>
@@ -3446,7 +3446,7 @@
             <a:r>
               <a:rPr lang="en-US" sz="1300" dirty="0">
                 <a:solidFill>
-                  <a:srgbClr val="0F172A"/>
+                  <a:srgbClr val="0A0A0A"/>
                 </a:solidFill>
               </a:rPr>
               <a:t>Org Training via KnowBe4</a:t>
@@ -3470,11 +3470,11 @@
             <a:avLst/>
           </a:prstGeom>
           <a:solidFill>
-            <a:srgbClr val="FFFFFF"/>
+            <a:srgbClr val="F5F5F5"/>
           </a:solidFill>
           <a:ln w="12700">
             <a:solidFill>
-              <a:srgbClr val="CADCFC"/>
+              <a:srgbClr val="E5E7EB"/>
             </a:solidFill>
             <a:prstDash val="solid"/>
           </a:ln>
@@ -3502,7 +3502,7 @@
             <a:avLst/>
           </a:prstGeom>
           <a:solidFill>
-            <a:srgbClr val="F59E0B"/>
+            <a:srgbClr val="D4AF37"/>
           </a:solidFill>
           <a:ln/>
         </p:spPr>
@@ -3534,7 +3534,7 @@
             <a:r>
               <a:rPr lang="en-US" sz="1800" b="1" dirty="0">
                 <a:solidFill>
-                  <a:srgbClr val="1E2761"/>
+                  <a:srgbClr val="111111"/>
                 </a:solidFill>
                 <a:latin typeface="Georgia" pitchFamily="34" charset="0"/>
                 <a:ea typeface="Georgia" pitchFamily="34" charset="-122"/>
@@ -3574,7 +3574,7 @@
             <a:r>
               <a:rPr lang="en-US" sz="1300" dirty="0">
                 <a:solidFill>
-                  <a:srgbClr val="0F172A"/>
+                  <a:srgbClr val="0A0A0A"/>
                 </a:solidFill>
               </a:rPr>
               <a:t>AWS, Azure, GCP</a:t>
@@ -3589,7 +3589,7 @@
             <a:r>
               <a:rPr lang="en-US" sz="1300" dirty="0">
                 <a:solidFill>
-                  <a:srgbClr val="0F172A"/>
+                  <a:srgbClr val="0A0A0A"/>
                 </a:solidFill>
               </a:rPr>
               <a:t>IAM / RBAC / Azure AD</a:t>
@@ -3604,7 +3604,7 @@
             <a:r>
               <a:rPr lang="en-US" sz="1300" dirty="0">
                 <a:solidFill>
-                  <a:srgbClr val="0F172A"/>
+                  <a:srgbClr val="0A0A0A"/>
                 </a:solidFill>
               </a:rPr>
               <a:t>VMware, Hyper-V, Docker</a:t>
@@ -3619,7 +3619,7 @@
             <a:r>
               <a:rPr lang="en-US" sz="1300" dirty="0">
                 <a:solidFill>
-                  <a:srgbClr val="0F172A"/>
+                  <a:srgbClr val="0A0A0A"/>
                 </a:solidFill>
               </a:rPr>
               <a:t>M365 &amp; SaaS Admin</a:t>
@@ -3643,11 +3643,11 @@
             <a:avLst/>
           </a:prstGeom>
           <a:solidFill>
-            <a:srgbClr val="FFFFFF"/>
+            <a:srgbClr val="F5F5F5"/>
           </a:solidFill>
           <a:ln w="12700">
             <a:solidFill>
-              <a:srgbClr val="CADCFC"/>
+              <a:srgbClr val="E5E7EB"/>
             </a:solidFill>
             <a:prstDash val="solid"/>
           </a:ln>
@@ -3675,7 +3675,7 @@
             <a:avLst/>
           </a:prstGeom>
           <a:solidFill>
-            <a:srgbClr val="F59E0B"/>
+            <a:srgbClr val="D4AF37"/>
           </a:solidFill>
           <a:ln/>
         </p:spPr>
@@ -3707,7 +3707,7 @@
             <a:r>
               <a:rPr lang="en-US" sz="1800" b="1" dirty="0">
                 <a:solidFill>
-                  <a:srgbClr val="1E2761"/>
+                  <a:srgbClr val="111111"/>
                 </a:solidFill>
                 <a:latin typeface="Georgia" pitchFamily="34" charset="0"/>
                 <a:ea typeface="Georgia" pitchFamily="34" charset="-122"/>
@@ -3747,7 +3747,7 @@
             <a:r>
               <a:rPr lang="en-US" sz="1300" dirty="0">
                 <a:solidFill>
-                  <a:srgbClr val="0F172A"/>
+                  <a:srgbClr val="0A0A0A"/>
                 </a:solidFill>
               </a:rPr>
               <a:t>GDPR, SOX, ITIL</a:t>
@@ -3762,7 +3762,7 @@
             <a:r>
               <a:rPr lang="en-US" sz="1300" dirty="0">
                 <a:solidFill>
-                  <a:srgbClr val="0F172A"/>
+                  <a:srgbClr val="0A0A0A"/>
                 </a:solidFill>
               </a:rPr>
               <a:t>Risk Assessment</a:t>
@@ -3777,7 +3777,7 @@
             <a:r>
               <a:rPr lang="en-US" sz="1300" dirty="0">
                 <a:solidFill>
-                  <a:srgbClr val="0F172A"/>
+                  <a:srgbClr val="0A0A0A"/>
                 </a:solidFill>
               </a:rPr>
               <a:t>Vulnerability Management</a:t>
@@ -3792,7 +3792,7 @@
             <a:r>
               <a:rPr lang="en-US" sz="1300" dirty="0">
                 <a:solidFill>
-                  <a:srgbClr val="0F172A"/>
+                  <a:srgbClr val="0A0A0A"/>
                 </a:solidFill>
               </a:rPr>
               <a:t>Security Policy Design</a:t>
@@ -3816,11 +3816,11 @@
             <a:avLst/>
           </a:prstGeom>
           <a:solidFill>
-            <a:srgbClr val="FFFFFF"/>
+            <a:srgbClr val="F5F5F5"/>
           </a:solidFill>
           <a:ln w="12700">
             <a:solidFill>
-              <a:srgbClr val="CADCFC"/>
+              <a:srgbClr val="E5E7EB"/>
             </a:solidFill>
             <a:prstDash val="solid"/>
           </a:ln>
@@ -3848,7 +3848,7 @@
             <a:avLst/>
           </a:prstGeom>
           <a:solidFill>
-            <a:srgbClr val="F59E0B"/>
+            <a:srgbClr val="D4AF37"/>
           </a:solidFill>
           <a:ln/>
         </p:spPr>
@@ -3880,7 +3880,7 @@
             <a:r>
               <a:rPr lang="en-US" sz="1800" b="1" dirty="0">
                 <a:solidFill>
-                  <a:srgbClr val="1E2761"/>
+                  <a:srgbClr val="111111"/>
                 </a:solidFill>
                 <a:latin typeface="Georgia" pitchFamily="34" charset="0"/>
                 <a:ea typeface="Georgia" pitchFamily="34" charset="-122"/>
@@ -3920,7 +3920,7 @@
             <a:r>
               <a:rPr lang="en-US" sz="1300" dirty="0">
                 <a:solidFill>
-                  <a:srgbClr val="0F172A"/>
+                  <a:srgbClr val="0A0A0A"/>
                 </a:solidFill>
               </a:rPr>
               <a:t>PowerShell, Python, SQL</a:t>
@@ -3935,7 +3935,7 @@
             <a:r>
               <a:rPr lang="en-US" sz="1300" dirty="0">
                 <a:solidFill>
-                  <a:srgbClr val="0F172A"/>
+                  <a:srgbClr val="0A0A0A"/>
                 </a:solidFill>
               </a:rPr>
               <a:t>Excel (Pivot Tables, VLOOKUP)</a:t>
@@ -3950,7 +3950,7 @@
             <a:r>
               <a:rPr lang="en-US" sz="1300" dirty="0">
                 <a:solidFill>
-                  <a:srgbClr val="0F172A"/>
+                  <a:srgbClr val="0A0A0A"/>
                 </a:solidFill>
               </a:rPr>
               <a:t>Power BI, Tableau &amp; LLMs</a:t>
@@ -3965,7 +3965,7 @@
             <a:r>
               <a:rPr lang="en-US" sz="1300" dirty="0">
                 <a:solidFill>
-                  <a:srgbClr val="0F172A"/>
+                  <a:srgbClr val="0A0A0A"/>
                 </a:solidFill>
               </a:rPr>
               <a:t>Predictive Modeling &amp; Automation</a:t>
@@ -3989,7 +3989,7 @@
             <a:avLst/>
           </a:prstGeom>
           <a:solidFill>
-            <a:srgbClr val="1E2761"/>
+            <a:srgbClr val="111111"/>
           </a:solidFill>
           <a:ln/>
         </p:spPr>
@@ -4021,7 +4021,7 @@
             <a:r>
               <a:rPr lang="en-US" sz="1000" dirty="0">
                 <a:solidFill>
-                  <a:srgbClr val="CADCFC"/>
+                  <a:srgbClr val="E5E7EB"/>
                 </a:solidFill>
               </a:rPr>
               <a:t>Tracey Scott  |  Cybersecurity • Cloud • SOC  |  traceysscott82@gmail.com</a:t>
@@ -4057,7 +4057,7 @@
             <a:r>
               <a:rPr lang="en-US" sz="1000" dirty="0">
                 <a:solidFill>
-                  <a:srgbClr val="CADCFC"/>
+                  <a:srgbClr val="E5E7EB"/>
                 </a:solidFill>
               </a:rPr>
               <a:t>3</a:t>
@@ -4080,7 +4080,7 @@
     <p:bg>
       <p:bgPr>
         <a:solidFill>
-          <a:srgbClr val="FFFFFF"/>
+          <a:srgbClr val="F5F5F5"/>
         </a:solidFill>
       </p:bgPr>
     </p:bg>
@@ -4125,7 +4125,7 @@
             <a:r>
               <a:rPr lang="en-US" sz="3600" b="1" dirty="0">
                 <a:solidFill>
-                  <a:srgbClr val="1E2761"/>
+                  <a:srgbClr val="111111"/>
                 </a:solidFill>
                 <a:latin typeface="Georgia" pitchFamily="34" charset="0"/>
                 <a:ea typeface="Georgia" pitchFamily="34" charset="-122"/>
@@ -4164,7 +4164,7 @@
             <a:r>
               <a:rPr lang="en-US" sz="1400" i="1" dirty="0">
                 <a:solidFill>
-                  <a:srgbClr val="64748B"/>
+                  <a:srgbClr val="9CA3AF"/>
                 </a:solidFill>
               </a:rPr>
               <a:t>Executive view I built at RightPath to monitor posture, incidents, and compliance.</a:t>
@@ -4188,7 +4188,7 @@
             <a:avLst/>
           </a:prstGeom>
           <a:solidFill>
-            <a:srgbClr val="1E2761"/>
+            <a:srgbClr val="111111"/>
           </a:solidFill>
           <a:ln/>
         </p:spPr>
@@ -4220,7 +4220,7 @@
             <a:r>
               <a:rPr lang="en-US" sz="3000" b="1" dirty="0">
                 <a:solidFill>
-                  <a:srgbClr val="F59E0B"/>
+                  <a:srgbClr val="D4AF37"/>
                 </a:solidFill>
                 <a:latin typeface="Georgia" pitchFamily="34" charset="0"/>
                 <a:ea typeface="Georgia" pitchFamily="34" charset="-122"/>
@@ -4259,7 +4259,7 @@
             <a:r>
               <a:rPr lang="en-US" sz="1200" dirty="0">
                 <a:solidFill>
-                  <a:srgbClr val="CADCFC"/>
+                  <a:srgbClr val="E5E7EB"/>
                 </a:solidFill>
               </a:rPr>
               <a:t>Uptime</a:t>
@@ -4283,7 +4283,7 @@
             <a:avLst/>
           </a:prstGeom>
           <a:solidFill>
-            <a:srgbClr val="1E2761"/>
+            <a:srgbClr val="111111"/>
           </a:solidFill>
           <a:ln/>
         </p:spPr>
@@ -4315,7 +4315,7 @@
             <a:r>
               <a:rPr lang="en-US" sz="3000" b="1" dirty="0">
                 <a:solidFill>
-                  <a:srgbClr val="F59E0B"/>
+                  <a:srgbClr val="D4AF37"/>
                 </a:solidFill>
                 <a:latin typeface="Georgia" pitchFamily="34" charset="0"/>
                 <a:ea typeface="Georgia" pitchFamily="34" charset="-122"/>
@@ -4354,7 +4354,7 @@
             <a:r>
               <a:rPr lang="en-US" sz="1200" dirty="0">
                 <a:solidFill>
-                  <a:srgbClr val="CADCFC"/>
+                  <a:srgbClr val="E5E7EB"/>
                 </a:solidFill>
               </a:rPr>
               <a:t>Critical Breaches</a:t>
@@ -4378,7 +4378,7 @@
             <a:avLst/>
           </a:prstGeom>
           <a:solidFill>
-            <a:srgbClr val="1E2761"/>
+            <a:srgbClr val="111111"/>
           </a:solidFill>
           <a:ln/>
         </p:spPr>
@@ -4410,7 +4410,7 @@
             <a:r>
               <a:rPr lang="en-US" sz="3000" b="1" dirty="0">
                 <a:solidFill>
-                  <a:srgbClr val="F59E0B"/>
+                  <a:srgbClr val="D4AF37"/>
                 </a:solidFill>
                 <a:latin typeface="Georgia" pitchFamily="34" charset="0"/>
                 <a:ea typeface="Georgia" pitchFamily="34" charset="-122"/>
@@ -4449,7 +4449,7 @@
             <a:r>
               <a:rPr lang="en-US" sz="1200" dirty="0">
                 <a:solidFill>
-                  <a:srgbClr val="CADCFC"/>
+                  <a:srgbClr val="E5E7EB"/>
                 </a:solidFill>
               </a:rPr>
               <a:t>Threats Mitigated</a:t>
@@ -4473,7 +4473,7 @@
             <a:avLst/>
           </a:prstGeom>
           <a:solidFill>
-            <a:srgbClr val="1E2761"/>
+            <a:srgbClr val="111111"/>
           </a:solidFill>
           <a:ln/>
         </p:spPr>
@@ -4505,7 +4505,7 @@
             <a:r>
               <a:rPr lang="en-US" sz="3000" b="1" dirty="0">
                 <a:solidFill>
-                  <a:srgbClr val="F59E0B"/>
+                  <a:srgbClr val="D4AF37"/>
                 </a:solidFill>
                 <a:latin typeface="Georgia" pitchFamily="34" charset="0"/>
                 <a:ea typeface="Georgia" pitchFamily="34" charset="-122"/>
@@ -4544,7 +4544,7 @@
             <a:r>
               <a:rPr lang="en-US" sz="1200" dirty="0">
                 <a:solidFill>
-                  <a:srgbClr val="CADCFC"/>
+                  <a:srgbClr val="E5E7EB"/>
                 </a:solidFill>
               </a:rPr>
               <a:t>RBAC Coverage</a:t>
@@ -4600,7 +4600,7 @@
             <a:avLst/>
           </a:prstGeom>
           <a:solidFill>
-            <a:srgbClr val="1E2761"/>
+            <a:srgbClr val="111111"/>
           </a:solidFill>
           <a:ln/>
         </p:spPr>
@@ -4632,7 +4632,7 @@
             <a:r>
               <a:rPr lang="en-US" sz="1000" dirty="0">
                 <a:solidFill>
-                  <a:srgbClr val="CADCFC"/>
+                  <a:srgbClr val="E5E7EB"/>
                 </a:solidFill>
               </a:rPr>
               <a:t>Tracey Scott  |  Cybersecurity • Cloud • SOC  |  traceysscott82@gmail.com</a:t>
@@ -4668,7 +4668,7 @@
             <a:r>
               <a:rPr lang="en-US" sz="1000" dirty="0">
                 <a:solidFill>
-                  <a:srgbClr val="CADCFC"/>
+                  <a:srgbClr val="E5E7EB"/>
                 </a:solidFill>
               </a:rPr>
               <a:t>4</a:t>
@@ -4691,7 +4691,7 @@
     <p:bg>
       <p:bgPr>
         <a:solidFill>
-          <a:srgbClr val="FFFFFF"/>
+          <a:srgbClr val="F5F5F5"/>
         </a:solidFill>
       </p:bgPr>
     </p:bg>
@@ -4736,7 +4736,7 @@
             <a:r>
               <a:rPr lang="en-US" sz="3600" b="1" dirty="0">
                 <a:solidFill>
-                  <a:srgbClr val="1E2761"/>
+                  <a:srgbClr val="111111"/>
                 </a:solidFill>
                 <a:latin typeface="Georgia" pitchFamily="34" charset="0"/>
                 <a:ea typeface="Georgia" pitchFamily="34" charset="-122"/>
@@ -4763,7 +4763,7 @@
             <a:avLst/>
           </a:prstGeom>
           <a:solidFill>
-            <a:srgbClr val="CADCFC"/>
+            <a:srgbClr val="E5E7EB"/>
           </a:solidFill>
           <a:ln/>
         </p:spPr>
@@ -4783,7 +4783,7 @@
             <a:avLst/>
           </a:prstGeom>
           <a:solidFill>
-            <a:srgbClr val="F59E0B"/>
+            <a:srgbClr val="D4AF37"/>
           </a:solidFill>
           <a:ln/>
         </p:spPr>
@@ -4815,7 +4815,7 @@
             <a:r>
               <a:rPr lang="en-US" sz="1300" b="1" dirty="0">
                 <a:solidFill>
-                  <a:srgbClr val="F59E0B"/>
+                  <a:srgbClr val="D4AF37"/>
                 </a:solidFill>
                 <a:latin typeface="Georgia" pitchFamily="34" charset="0"/>
                 <a:ea typeface="Georgia" pitchFamily="34" charset="-122"/>
@@ -4854,7 +4854,7 @@
             <a:r>
               <a:rPr lang="en-US" sz="1400" b="1" dirty="0">
                 <a:solidFill>
-                  <a:srgbClr val="1E2761"/>
+                  <a:srgbClr val="111111"/>
                 </a:solidFill>
               </a:rPr>
               <a:t>Enterprise Security Framework</a:t>
@@ -4890,7 +4890,7 @@
             <a:r>
               <a:rPr lang="en-US" sz="1100" dirty="0">
                 <a:solidFill>
-                  <a:srgbClr val="0F172A"/>
+                  <a:srgbClr val="0A0A0A"/>
                 </a:solidFill>
               </a:rPr>
               <a:t>Architected endpoint, IDS/IPS, MDM, and access governance for startup in 6 months.</a:t>
@@ -4914,7 +4914,7 @@
             <a:avLst/>
           </a:prstGeom>
           <a:solidFill>
-            <a:srgbClr val="CADCFC"/>
+            <a:srgbClr val="E5E7EB"/>
           </a:solidFill>
           <a:ln/>
         </p:spPr>
@@ -4934,7 +4934,7 @@
             <a:avLst/>
           </a:prstGeom>
           <a:solidFill>
-            <a:srgbClr val="F59E0B"/>
+            <a:srgbClr val="D4AF37"/>
           </a:solidFill>
           <a:ln/>
         </p:spPr>
@@ -4966,7 +4966,7 @@
             <a:r>
               <a:rPr lang="en-US" sz="1300" b="1" dirty="0">
                 <a:solidFill>
-                  <a:srgbClr val="F59E0B"/>
+                  <a:srgbClr val="D4AF37"/>
                 </a:solidFill>
                 <a:latin typeface="Georgia" pitchFamily="34" charset="0"/>
                 <a:ea typeface="Georgia" pitchFamily="34" charset="-122"/>
@@ -5005,7 +5005,7 @@
             <a:r>
               <a:rPr lang="en-US" sz="1400" b="1" dirty="0">
                 <a:solidFill>
-                  <a:srgbClr val="1E2761"/>
+                  <a:srgbClr val="111111"/>
                 </a:solidFill>
               </a:rPr>
               <a:t>Secure Multi-Cloud Deployment</a:t>
@@ -5041,7 +5041,7 @@
             <a:r>
               <a:rPr lang="en-US" sz="1100" dirty="0">
                 <a:solidFill>
-                  <a:srgbClr val="0F172A"/>
+                  <a:srgbClr val="0A0A0A"/>
                 </a:solidFill>
               </a:rPr>
               <a:t>AWS + Azure infrastructure with IAM, RBAC, encryption, and least-privilege controls.</a:t>
@@ -5065,7 +5065,7 @@
             <a:avLst/>
           </a:prstGeom>
           <a:solidFill>
-            <a:srgbClr val="CADCFC"/>
+            <a:srgbClr val="E5E7EB"/>
           </a:solidFill>
           <a:ln/>
         </p:spPr>
@@ -5085,7 +5085,7 @@
             <a:avLst/>
           </a:prstGeom>
           <a:solidFill>
-            <a:srgbClr val="F59E0B"/>
+            <a:srgbClr val="D4AF37"/>
           </a:solidFill>
           <a:ln/>
         </p:spPr>
@@ -5117,7 +5117,7 @@
             <a:r>
               <a:rPr lang="en-US" sz="1300" b="1" dirty="0">
                 <a:solidFill>
-                  <a:srgbClr val="F59E0B"/>
+                  <a:srgbClr val="D4AF37"/>
                 </a:solidFill>
                 <a:latin typeface="Georgia" pitchFamily="34" charset="0"/>
                 <a:ea typeface="Georgia" pitchFamily="34" charset="-122"/>
@@ -5156,7 +5156,7 @@
             <a:r>
               <a:rPr lang="en-US" sz="1400" b="1" dirty="0">
                 <a:solidFill>
-                  <a:srgbClr val="1E2761"/>
+                  <a:srgbClr val="111111"/>
                 </a:solidFill>
               </a:rPr>
               <a:t>CRM Secure Deployment</a:t>
@@ -5192,7 +5192,7 @@
             <a:r>
               <a:rPr lang="en-US" sz="1100" dirty="0">
                 <a:solidFill>
-                  <a:srgbClr val="0F172A"/>
+                  <a:srgbClr val="0A0A0A"/>
                 </a:solidFill>
               </a:rPr>
               <a:t>Complete CRM build — coding, development, maintenance, secure auth, encryption, RBAC.</a:t>
@@ -5216,7 +5216,7 @@
             <a:avLst/>
           </a:prstGeom>
           <a:solidFill>
-            <a:srgbClr val="CADCFC"/>
+            <a:srgbClr val="E5E7EB"/>
           </a:solidFill>
           <a:ln/>
         </p:spPr>
@@ -5236,7 +5236,7 @@
             <a:avLst/>
           </a:prstGeom>
           <a:solidFill>
-            <a:srgbClr val="F59E0B"/>
+            <a:srgbClr val="D4AF37"/>
           </a:solidFill>
           <a:ln/>
         </p:spPr>
@@ -5268,7 +5268,7 @@
             <a:r>
               <a:rPr lang="en-US" sz="1300" b="1" dirty="0">
                 <a:solidFill>
-                  <a:srgbClr val="F59E0B"/>
+                  <a:srgbClr val="D4AF37"/>
                 </a:solidFill>
                 <a:latin typeface="Georgia" pitchFamily="34" charset="0"/>
                 <a:ea typeface="Georgia" pitchFamily="34" charset="-122"/>
@@ -5307,7 +5307,7 @@
             <a:r>
               <a:rPr lang="en-US" sz="1400" b="1" dirty="0">
                 <a:solidFill>
-                  <a:srgbClr val="1E2761"/>
+                  <a:srgbClr val="111111"/>
                 </a:solidFill>
               </a:rPr>
               <a:t>Executive Dashboards</a:t>
@@ -5343,7 +5343,7 @@
             <a:r>
               <a:rPr lang="en-US" sz="1100" dirty="0">
                 <a:solidFill>
-                  <a:srgbClr val="0F172A"/>
+                  <a:srgbClr val="0A0A0A"/>
                 </a:solidFill>
               </a:rPr>
               <a:t>Power BI dashboards for incidents, compliance, and sales metrics — auditing, trends &amp; revenue forecasting.</a:t>
@@ -5367,7 +5367,7 @@
             <a:avLst/>
           </a:prstGeom>
           <a:solidFill>
-            <a:srgbClr val="CADCFC"/>
+            <a:srgbClr val="E5E7EB"/>
           </a:solidFill>
           <a:ln/>
         </p:spPr>
@@ -5387,7 +5387,7 @@
             <a:avLst/>
           </a:prstGeom>
           <a:solidFill>
-            <a:srgbClr val="F59E0B"/>
+            <a:srgbClr val="D4AF37"/>
           </a:solidFill>
           <a:ln/>
         </p:spPr>
@@ -5419,7 +5419,7 @@
             <a:r>
               <a:rPr lang="en-US" sz="1300" b="1" dirty="0">
                 <a:solidFill>
-                  <a:srgbClr val="F59E0B"/>
+                  <a:srgbClr val="D4AF37"/>
                 </a:solidFill>
                 <a:latin typeface="Georgia" pitchFamily="34" charset="0"/>
                 <a:ea typeface="Georgia" pitchFamily="34" charset="-122"/>
@@ -5458,7 +5458,7 @@
             <a:r>
               <a:rPr lang="en-US" sz="1400" b="1" dirty="0">
                 <a:solidFill>
-                  <a:srgbClr val="1E2761"/>
+                  <a:srgbClr val="111111"/>
                 </a:solidFill>
               </a:rPr>
               <a:t>Incident Response &amp; KnowBe4</a:t>
@@ -5494,7 +5494,7 @@
             <a:r>
               <a:rPr lang="en-US" sz="1100" dirty="0">
                 <a:solidFill>
-                  <a:srgbClr val="0F172A"/>
+                  <a:srgbClr val="0A0A0A"/>
                 </a:solidFill>
               </a:rPr>
               <a:t>IR playbooks, remediation workflows, and org-wide KnowBe4 security awareness training.</a:t>
@@ -5518,7 +5518,7 @@
             <a:avLst/>
           </a:prstGeom>
           <a:solidFill>
-            <a:srgbClr val="CADCFC"/>
+            <a:srgbClr val="E5E7EB"/>
           </a:solidFill>
           <a:ln/>
         </p:spPr>
@@ -5538,7 +5538,7 @@
             <a:avLst/>
           </a:prstGeom>
           <a:solidFill>
-            <a:srgbClr val="F59E0B"/>
+            <a:srgbClr val="D4AF37"/>
           </a:solidFill>
           <a:ln/>
         </p:spPr>
@@ -5570,7 +5570,7 @@
             <a:r>
               <a:rPr lang="en-US" sz="1300" b="1" dirty="0">
                 <a:solidFill>
-                  <a:srgbClr val="F59E0B"/>
+                  <a:srgbClr val="D4AF37"/>
                 </a:solidFill>
                 <a:latin typeface="Georgia" pitchFamily="34" charset="0"/>
                 <a:ea typeface="Georgia" pitchFamily="34" charset="-122"/>
@@ -5609,7 +5609,7 @@
             <a:r>
               <a:rPr lang="en-US" sz="1400" b="1" dirty="0">
                 <a:solidFill>
-                  <a:srgbClr val="1E2761"/>
+                  <a:srgbClr val="111111"/>
                 </a:solidFill>
               </a:rPr>
               <a:t>IT Ticketing System</a:t>
@@ -5645,7 +5645,7 @@
             <a:r>
               <a:rPr lang="en-US" sz="1100" dirty="0">
                 <a:solidFill>
-                  <a:srgbClr val="0F172A"/>
+                  <a:srgbClr val="0A0A0A"/>
                 </a:solidFill>
               </a:rPr>
               <a:t>Built ticketing system for org-wide issue reporting, triage, and resolution tracking.</a:t>
@@ -5669,7 +5669,7 @@
             <a:avLst/>
           </a:prstGeom>
           <a:solidFill>
-            <a:srgbClr val="CADCFC"/>
+            <a:srgbClr val="E5E7EB"/>
           </a:solidFill>
           <a:ln/>
         </p:spPr>
@@ -5689,7 +5689,7 @@
             <a:avLst/>
           </a:prstGeom>
           <a:solidFill>
-            <a:srgbClr val="F59E0B"/>
+            <a:srgbClr val="D4AF37"/>
           </a:solidFill>
           <a:ln/>
         </p:spPr>
@@ -5721,7 +5721,7 @@
             <a:r>
               <a:rPr lang="en-US" sz="1300" b="1" dirty="0">
                 <a:solidFill>
-                  <a:srgbClr val="F59E0B"/>
+                  <a:srgbClr val="D4AF37"/>
                 </a:solidFill>
                 <a:latin typeface="Georgia" pitchFamily="34" charset="0"/>
                 <a:ea typeface="Georgia" pitchFamily="34" charset="-122"/>
@@ -5760,7 +5760,7 @@
             <a:r>
               <a:rPr lang="en-US" sz="1400" b="1" dirty="0">
                 <a:solidFill>
-                  <a:srgbClr val="1E2761"/>
+                  <a:srgbClr val="111111"/>
                 </a:solidFill>
               </a:rPr>
               <a:t>Internal AI Chatbots (LLM)</a:t>
@@ -5796,7 +5796,7 @@
             <a:r>
               <a:rPr lang="en-US" sz="1100" dirty="0">
                 <a:solidFill>
-                  <a:srgbClr val="0F172A"/>
+                  <a:srgbClr val="0A0A0A"/>
                 </a:solidFill>
               </a:rPr>
               <a:t>LLM-powered chatbots for multiple departments with CRM, Microsoft 365, and SharePoint connectivity.</a:t>
@@ -5820,7 +5820,7 @@
             <a:avLst/>
           </a:prstGeom>
           <a:solidFill>
-            <a:srgbClr val="1E2761"/>
+            <a:srgbClr val="111111"/>
           </a:solidFill>
           <a:ln/>
         </p:spPr>
@@ -5852,7 +5852,7 @@
             <a:r>
               <a:rPr lang="en-US" sz="1000" dirty="0">
                 <a:solidFill>
-                  <a:srgbClr val="CADCFC"/>
+                  <a:srgbClr val="E5E7EB"/>
                 </a:solidFill>
               </a:rPr>
               <a:t>Tracey Scott  |  Cybersecurity • Cloud • SOC  |  traceysscott82@gmail.com</a:t>
@@ -5888,7 +5888,7 @@
             <a:r>
               <a:rPr lang="en-US" sz="1000" dirty="0">
                 <a:solidFill>
-                  <a:srgbClr val="CADCFC"/>
+                  <a:srgbClr val="E5E7EB"/>
                 </a:solidFill>
               </a:rPr>
               <a:t>5</a:t>
@@ -5911,7 +5911,7 @@
     <p:bg>
       <p:bgPr>
         <a:solidFill>
-          <a:srgbClr val="FFFFFF"/>
+          <a:srgbClr val="F5F5F5"/>
         </a:solidFill>
       </p:bgPr>
     </p:bg>
@@ -5956,7 +5956,7 @@
             <a:r>
               <a:rPr lang="en-US" sz="3600" b="1" dirty="0">
                 <a:solidFill>
-                  <a:srgbClr val="1E2761"/>
+                  <a:srgbClr val="111111"/>
                 </a:solidFill>
                 <a:latin typeface="Georgia" pitchFamily="34" charset="0"/>
                 <a:ea typeface="Georgia" pitchFamily="34" charset="-122"/>
@@ -5995,7 +5995,7 @@
             <a:r>
               <a:rPr lang="en-US" sz="1400" i="1" dirty="0">
                 <a:solidFill>
-                  <a:srgbClr val="64748B"/>
+                  <a:srgbClr val="9CA3AF"/>
                 </a:solidFill>
               </a:rPr>
               <a:t>Self-assessed proficiency across the stack I use in production.</a:t>
@@ -6035,7 +6035,7 @@
             <a:avLst/>
           </a:prstGeom>
           <a:solidFill>
-            <a:srgbClr val="1E2761"/>
+            <a:srgbClr val="111111"/>
           </a:solidFill>
           <a:ln/>
         </p:spPr>
@@ -6067,7 +6067,7 @@
             <a:r>
               <a:rPr lang="en-US" sz="1000" dirty="0">
                 <a:solidFill>
-                  <a:srgbClr val="CADCFC"/>
+                  <a:srgbClr val="E5E7EB"/>
                 </a:solidFill>
               </a:rPr>
               <a:t>Tracey Scott  |  Cybersecurity • Cloud • SOC  |  traceysscott82@gmail.com</a:t>
@@ -6103,7 +6103,7 @@
             <a:r>
               <a:rPr lang="en-US" sz="1000" dirty="0">
                 <a:solidFill>
-                  <a:srgbClr val="CADCFC"/>
+                  <a:srgbClr val="E5E7EB"/>
                 </a:solidFill>
               </a:rPr>
               <a:t>6</a:t>
@@ -6126,7 +6126,7 @@
     <p:bg>
       <p:bgPr>
         <a:solidFill>
-          <a:srgbClr val="1E2761"/>
+          <a:srgbClr val="111111"/>
         </a:solidFill>
       </p:bgPr>
     </p:bg>
@@ -6171,7 +6171,7 @@
             <a:r>
               <a:rPr lang="en-US" sz="3600" b="1" dirty="0">
                 <a:solidFill>
-                  <a:srgbClr val="FFFFFF"/>
+                  <a:srgbClr val="F5F5F5"/>
                 </a:solidFill>
                 <a:latin typeface="Georgia" pitchFamily="34" charset="0"/>
                 <a:ea typeface="Georgia" pitchFamily="34" charset="-122"/>
@@ -6198,7 +6198,7 @@
             <a:avLst/>
           </a:prstGeom>
           <a:solidFill>
-            <a:srgbClr val="F59E0B"/>
+            <a:srgbClr val="D4AF37"/>
           </a:solidFill>
           <a:ln/>
         </p:spPr>
@@ -6218,13 +6218,13 @@
             <a:avLst/>
           </a:prstGeom>
           <a:solidFill>
-            <a:srgbClr val="FFFFFF">
+            <a:srgbClr val="F5F5F5">
               <a:alpha val="10000"/>
             </a:srgbClr>
           </a:solidFill>
           <a:ln w="12700">
             <a:solidFill>
-              <a:srgbClr val="CADCFC"/>
+              <a:srgbClr val="E5E7EB"/>
             </a:solidFill>
             <a:prstDash val="solid"/>
           </a:ln>
@@ -6257,7 +6257,7 @@
             <a:r>
               <a:rPr lang="en-US" sz="4400" b="1" dirty="0">
                 <a:solidFill>
-                  <a:srgbClr val="F59E0B"/>
+                  <a:srgbClr val="D4AF37"/>
                 </a:solidFill>
                 <a:latin typeface="Georgia" pitchFamily="34" charset="0"/>
                 <a:ea typeface="Georgia" pitchFamily="34" charset="-122"/>
@@ -6296,7 +6296,7 @@
             <a:r>
               <a:rPr lang="en-US" sz="1300" dirty="0">
                 <a:solidFill>
-                  <a:srgbClr val="FFFFFF"/>
+                  <a:srgbClr val="F5F5F5"/>
                 </a:solidFill>
               </a:rPr>
               <a:t>Full security framework stood up from zero</a:t>
@@ -6320,13 +6320,13 @@
             <a:avLst/>
           </a:prstGeom>
           <a:solidFill>
-            <a:srgbClr val="FFFFFF">
+            <a:srgbClr val="F5F5F5">
               <a:alpha val="10000"/>
             </a:srgbClr>
           </a:solidFill>
           <a:ln w="12700">
             <a:solidFill>
-              <a:srgbClr val="CADCFC"/>
+              <a:srgbClr val="E5E7EB"/>
             </a:solidFill>
             <a:prstDash val="solid"/>
           </a:ln>
@@ -6359,7 +6359,7 @@
             <a:r>
               <a:rPr lang="en-US" sz="4400" b="1" dirty="0">
                 <a:solidFill>
-                  <a:srgbClr val="F59E0B"/>
+                  <a:srgbClr val="D4AF37"/>
                 </a:solidFill>
                 <a:latin typeface="Georgia" pitchFamily="34" charset="0"/>
                 <a:ea typeface="Georgia" pitchFamily="34" charset="-122"/>
@@ -6398,7 +6398,7 @@
             <a:r>
               <a:rPr lang="en-US" sz="1300" dirty="0">
                 <a:solidFill>
-                  <a:srgbClr val="FFFFFF"/>
+                  <a:srgbClr val="F5F5F5"/>
                 </a:solidFill>
               </a:rPr>
               <a:t>Predictive model accuracy delivered to stakeholders</a:t>
@@ -6422,13 +6422,13 @@
             <a:avLst/>
           </a:prstGeom>
           <a:solidFill>
-            <a:srgbClr val="FFFFFF">
+            <a:srgbClr val="F5F5F5">
               <a:alpha val="10000"/>
             </a:srgbClr>
           </a:solidFill>
           <a:ln w="12700">
             <a:solidFill>
-              <a:srgbClr val="CADCFC"/>
+              <a:srgbClr val="E5E7EB"/>
             </a:solidFill>
             <a:prstDash val="solid"/>
           </a:ln>
@@ -6461,7 +6461,7 @@
             <a:r>
               <a:rPr lang="en-US" sz="4400" b="1" dirty="0">
                 <a:solidFill>
-                  <a:srgbClr val="F59E0B"/>
+                  <a:srgbClr val="D4AF37"/>
                 </a:solidFill>
                 <a:latin typeface="Georgia" pitchFamily="34" charset="0"/>
                 <a:ea typeface="Georgia" pitchFamily="34" charset="-122"/>
@@ -6500,7 +6500,7 @@
             <a:r>
               <a:rPr lang="en-US" sz="1300" dirty="0">
                 <a:solidFill>
-                  <a:srgbClr val="FFFFFF"/>
+                  <a:srgbClr val="F5F5F5"/>
                 </a:solidFill>
               </a:rPr>
               <a:t>Reporting accuracy gain through data validation</a:t>
@@ -6524,13 +6524,13 @@
             <a:avLst/>
           </a:prstGeom>
           <a:solidFill>
-            <a:srgbClr val="FFFFFF">
+            <a:srgbClr val="F5F5F5">
               <a:alpha val="10000"/>
             </a:srgbClr>
           </a:solidFill>
           <a:ln w="12700">
             <a:solidFill>
-              <a:srgbClr val="CADCFC"/>
+              <a:srgbClr val="E5E7EB"/>
             </a:solidFill>
             <a:prstDash val="solid"/>
           </a:ln>
@@ -6563,7 +6563,7 @@
             <a:r>
               <a:rPr lang="en-US" sz="4400" b="1" dirty="0">
                 <a:solidFill>
-                  <a:srgbClr val="F59E0B"/>
+                  <a:srgbClr val="D4AF37"/>
                 </a:solidFill>
                 <a:latin typeface="Georgia" pitchFamily="34" charset="0"/>
                 <a:ea typeface="Georgia" pitchFamily="34" charset="-122"/>
@@ -6602,7 +6602,7 @@
             <a:r>
               <a:rPr lang="en-US" sz="1300" dirty="0">
                 <a:solidFill>
-                  <a:srgbClr val="FFFFFF"/>
+                  <a:srgbClr val="F5F5F5"/>
                 </a:solidFill>
               </a:rPr>
               <a:t>RBAC / least-privilege coverage across hybrid env</a:t>
@@ -6626,13 +6626,13 @@
             <a:avLst/>
           </a:prstGeom>
           <a:solidFill>
-            <a:srgbClr val="FFFFFF">
+            <a:srgbClr val="F5F5F5">
               <a:alpha val="10000"/>
             </a:srgbClr>
           </a:solidFill>
           <a:ln w="12700">
             <a:solidFill>
-              <a:srgbClr val="CADCFC"/>
+              <a:srgbClr val="E5E7EB"/>
             </a:solidFill>
             <a:prstDash val="solid"/>
           </a:ln>
@@ -6665,7 +6665,7 @@
             <a:r>
               <a:rPr lang="en-US" sz="4400" b="1" dirty="0">
                 <a:solidFill>
-                  <a:srgbClr val="F59E0B"/>
+                  <a:srgbClr val="D4AF37"/>
                 </a:solidFill>
                 <a:latin typeface="Georgia" pitchFamily="34" charset="0"/>
                 <a:ea typeface="Georgia" pitchFamily="34" charset="-122"/>
@@ -6704,7 +6704,7 @@
             <a:r>
               <a:rPr lang="en-US" sz="1300" dirty="0">
                 <a:solidFill>
-                  <a:srgbClr val="FFFFFF"/>
+                  <a:srgbClr val="F5F5F5"/>
                 </a:solidFill>
               </a:rPr>
               <a:t>Critical incidents since framework rollout</a:t>
@@ -6728,13 +6728,13 @@
             <a:avLst/>
           </a:prstGeom>
           <a:solidFill>
-            <a:srgbClr val="FFFFFF">
+            <a:srgbClr val="F5F5F5">
               <a:alpha val="10000"/>
             </a:srgbClr>
           </a:solidFill>
           <a:ln w="12700">
             <a:solidFill>
-              <a:srgbClr val="CADCFC"/>
+              <a:srgbClr val="E5E7EB"/>
             </a:solidFill>
             <a:prstDash val="solid"/>
           </a:ln>
@@ -6767,7 +6767,7 @@
             <a:r>
               <a:rPr lang="en-US" sz="4400" b="1" dirty="0">
                 <a:solidFill>
-                  <a:srgbClr val="F59E0B"/>
+                  <a:srgbClr val="D4AF37"/>
                 </a:solidFill>
                 <a:latin typeface="Georgia" pitchFamily="34" charset="0"/>
                 <a:ea typeface="Georgia" pitchFamily="34" charset="-122"/>
@@ -6806,7 +6806,7 @@
             <a:r>
               <a:rPr lang="en-US" sz="1300" dirty="0">
                 <a:solidFill>
-                  <a:srgbClr val="FFFFFF"/>
+                  <a:srgbClr val="F5F5F5"/>
                 </a:solidFill>
               </a:rPr>
               <a:t>Public clouds secured and administered (AWS/Azure/GCP)</a:t>
@@ -6830,7 +6830,7 @@
             <a:avLst/>
           </a:prstGeom>
           <a:solidFill>
-            <a:srgbClr val="1E2761"/>
+            <a:srgbClr val="111111"/>
           </a:solidFill>
           <a:ln/>
         </p:spPr>
@@ -6862,7 +6862,7 @@
             <a:r>
               <a:rPr lang="en-US" sz="1000" dirty="0">
                 <a:solidFill>
-                  <a:srgbClr val="CADCFC"/>
+                  <a:srgbClr val="E5E7EB"/>
                 </a:solidFill>
               </a:rPr>
               <a:t>Tracey Scott  |  Cybersecurity • Cloud • SOC  |  traceysscott82@gmail.com</a:t>
@@ -6898,7 +6898,7 @@
             <a:r>
               <a:rPr lang="en-US" sz="1000" dirty="0">
                 <a:solidFill>
-                  <a:srgbClr val="CADCFC"/>
+                  <a:srgbClr val="E5E7EB"/>
                 </a:solidFill>
               </a:rPr>
               <a:t>7</a:t>
@@ -6921,7 +6921,7 @@
     <p:bg>
       <p:bgPr>
         <a:solidFill>
-          <a:srgbClr val="FFFFFF"/>
+          <a:srgbClr val="F5F5F5"/>
         </a:solidFill>
       </p:bgPr>
     </p:bg>
@@ -6966,7 +6966,7 @@
             <a:r>
               <a:rPr lang="en-US" sz="4000" b="1" dirty="0">
                 <a:solidFill>
-                  <a:srgbClr val="1E2761"/>
+                  <a:srgbClr val="111111"/>
                 </a:solidFill>
                 <a:latin typeface="Georgia" pitchFamily="34" charset="0"/>
                 <a:ea typeface="Georgia" pitchFamily="34" charset="-122"/>
@@ -6993,7 +6993,7 @@
             <a:avLst/>
           </a:prstGeom>
           <a:solidFill>
-            <a:srgbClr val="CADCFC"/>
+            <a:srgbClr val="E5E7EB"/>
           </a:solidFill>
           <a:ln/>
         </p:spPr>
@@ -7025,7 +7025,7 @@
             <a:r>
               <a:rPr lang="en-US" sz="2000" b="1" dirty="0">
                 <a:solidFill>
-                  <a:srgbClr val="1E2761"/>
+                  <a:srgbClr val="111111"/>
                 </a:solidFill>
               </a:rPr>
               <a:t>Professional Goals</a:t>
@@ -7065,7 +7065,7 @@
             <a:r>
               <a:rPr lang="en-US" sz="1500" dirty="0">
                 <a:solidFill>
-                  <a:srgbClr val="0F172A"/>
+                  <a:srgbClr val="0A0A0A"/>
                 </a:solidFill>
               </a:rPr>
               <a:t>Earned CISSP certification</a:t>
@@ -7083,7 +7083,7 @@
             <a:r>
               <a:rPr lang="en-US" sz="1500" dirty="0">
                 <a:solidFill>
-                  <a:srgbClr val="0F172A"/>
+                  <a:srgbClr val="0A0A0A"/>
                 </a:solidFill>
               </a:rPr>
               <a:t>Lead a cybersecurity operations team or SOC</a:t>
@@ -7101,7 +7101,7 @@
             <a:r>
               <a:rPr lang="en-US" sz="1500" dirty="0">
                 <a:solidFill>
-                  <a:srgbClr val="0F172A"/>
+                  <a:srgbClr val="0A0A0A"/>
                 </a:solidFill>
               </a:rPr>
               <a:t>Deepen cloud security automation &amp; IaC practice</a:t>
@@ -7119,7 +7119,7 @@
             <a:r>
               <a:rPr lang="en-US" sz="1500" dirty="0">
                 <a:solidFill>
-                  <a:srgbClr val="0F172A"/>
+                  <a:srgbClr val="0A0A0A"/>
                 </a:solidFill>
               </a:rPr>
               <a:t>Mentor women entering cybersecurity via RTC &amp; ISSA</a:t>
@@ -7134,7 +7134,7 @@
             <a:r>
               <a:rPr lang="en-US" sz="1500" dirty="0">
                 <a:solidFill>
-                  <a:srgbClr val="0F172A"/>
+                  <a:srgbClr val="0A0A0A"/>
                 </a:solidFill>
               </a:rPr>
               <a:t>Contribute to enterprise zero-trust architecture</a:t>
@@ -7158,7 +7158,7 @@
             <a:avLst/>
           </a:prstGeom>
           <a:solidFill>
-            <a:srgbClr val="1E2761"/>
+            <a:srgbClr val="111111"/>
           </a:solidFill>
           <a:ln/>
         </p:spPr>
@@ -7178,7 +7178,7 @@
             <a:avLst/>
           </a:prstGeom>
           <a:solidFill>
-            <a:srgbClr val="F59E0B"/>
+            <a:srgbClr val="D4AF37"/>
           </a:solidFill>
           <a:ln/>
         </p:spPr>
@@ -7210,7 +7210,7 @@
             <a:r>
               <a:rPr lang="en-US" sz="2400" b="1" dirty="0">
                 <a:solidFill>
-                  <a:srgbClr val="FFFFFF"/>
+                  <a:srgbClr val="F5F5F5"/>
                 </a:solidFill>
                 <a:latin typeface="Georgia" pitchFamily="34" charset="0"/>
                 <a:ea typeface="Georgia" pitchFamily="34" charset="-122"/>
@@ -7252,7 +7252,7 @@
             <a:r>
               <a:rPr lang="en-US" sz="1800" b="1" dirty="0">
                 <a:solidFill>
-                  <a:srgbClr val="F59E0B"/>
+                  <a:srgbClr val="D4AF37"/>
                 </a:solidFill>
               </a:rPr>
               <a:t>Tracey Scott</a:t>
@@ -7269,7 +7269,7 @@
             <a:r>
               <a:rPr lang="en-US" sz="1400" i="1" dirty="0">
                 <a:solidFill>
-                  <a:srgbClr val="CADCFC"/>
+                  <a:srgbClr val="E5E7EB"/>
                 </a:solidFill>
               </a:rPr>
               <a:t>IT Operations Manager &amp; Business Analyst</a:t>
@@ -7286,7 +7286,7 @@
             <a:r>
               <a:rPr lang="en-US" sz="1400" dirty="0">
                 <a:solidFill>
-                  <a:srgbClr val="FFFFFF"/>
+                  <a:srgbClr val="F5F5F5"/>
                 </a:solidFill>
               </a:rPr>
               <a:t>Greenville, SC</a:t>
@@ -7303,7 +7303,7 @@
             <a:r>
               <a:rPr lang="en-US" sz="1400" dirty="0">
                 <a:solidFill>
-                  <a:srgbClr val="FFFFFF"/>
+                  <a:srgbClr val="F5F5F5"/>
                 </a:solidFill>
               </a:rPr>
               <a:t>(864) 775-2929</a:t>
@@ -7320,7 +7320,7 @@
             <a:r>
               <a:rPr lang="en-US" sz="1400" dirty="0">
                 <a:solidFill>
-                  <a:srgbClr val="FFFFFF"/>
+                  <a:srgbClr val="F5F5F5"/>
                 </a:solidFill>
               </a:rPr>
               <a:t>traceysscott82@gmail.com</a:t>
@@ -7337,7 +7337,7 @@
             <a:r>
               <a:rPr lang="en-US" sz="1400" dirty="0">
                 <a:solidFill>
-                  <a:srgbClr val="FFFFFF"/>
+                  <a:srgbClr val="F5F5F5"/>
                 </a:solidFill>
               </a:rPr>
               <a:t>linkedin.com/in/traceysscott</a:t>
@@ -7351,7 +7351,7 @@
             <a:r>
               <a:rPr lang="en-US" sz="1400" b="1" dirty="0">
                 <a:solidFill>
-                  <a:srgbClr val="F59E0B"/>
+                  <a:srgbClr val="D4AF37"/>
                 </a:solidFill>
               </a:rPr>
               <a:t>traceytheanalyst.github.io</a:t>
@@ -7375,7 +7375,7 @@
             <a:avLst/>
           </a:prstGeom>
           <a:solidFill>
-            <a:srgbClr val="1E2761"/>
+            <a:srgbClr val="111111"/>
           </a:solidFill>
           <a:ln/>
         </p:spPr>
@@ -7407,7 +7407,7 @@
             <a:r>
               <a:rPr lang="en-US" sz="1000" dirty="0">
                 <a:solidFill>
-                  <a:srgbClr val="CADCFC"/>
+                  <a:srgbClr val="E5E7EB"/>
                 </a:solidFill>
               </a:rPr>
               <a:t>Tracey Scott  |  Cybersecurity • Cloud • SOC  |  traceysscott82@gmail.com</a:t>
@@ -7443,7 +7443,7 @@
             <a:r>
               <a:rPr lang="en-US" sz="1000" dirty="0">
                 <a:solidFill>
-                  <a:srgbClr val="CADCFC"/>
+                  <a:srgbClr val="E5E7EB"/>
                 </a:solidFill>
               </a:rPr>
               <a:t>8</a:t>

</xml_diff>

<commit_message>
Apply Cyber Neon palette
</commit_message>
<xml_diff>
--- a/Tracey-Scott-Portfolio.pptx
+++ b/Tracey-Scott-Portfolio.pptx
@@ -128,7 +128,7 @@
             <a:pPr>
               <a:defRPr sz="1400" b="0" i="0" u="none" strike="noStrike">
                 <a:solidFill>
-                  <a:srgbClr val="111111"/>
+                  <a:srgbClr val="0A0E27"/>
                 </a:solidFill>
                 <a:latin typeface="Arial"/>
               </a:defRPr>
@@ -136,7 +136,7 @@
             <a:r>
               <a:rPr sz="1400" b="0" i="0" u="none" strike="noStrike">
                 <a:solidFill>
-                  <a:srgbClr val="111111"/>
+                  <a:srgbClr val="0A0E27"/>
                 </a:solidFill>
                 <a:latin typeface="Arial"/>
               </a:rPr>
@@ -169,11 +169,11 @@
           </c:tx>
           <c:spPr>
             <a:solidFill>
-              <a:srgbClr val="D4AF37"/>
+              <a:srgbClr val="00F0FF"/>
             </a:solidFill>
             <a:ln w="38100" cap="flat">
               <a:solidFill>
-                <a:srgbClr val="D4AF37"/>
+                <a:srgbClr val="00F0FF"/>
               </a:solidFill>
               <a:prstDash val="solid"/>
               <a:round/>
@@ -190,7 +190,7 @@
                 <a:pPr>
                   <a:defRPr b="0" i="0" strike="noStrike" sz="1200" u="none">
                     <a:solidFill>
-                      <a:srgbClr val="0A0A0A"/>
+                      <a:srgbClr val="050816"/>
                     </a:solidFill>
                     <a:latin typeface="Arial"/>
                   </a:defRPr>
@@ -210,11 +210,11 @@
             <c:size val="6"/>
             <c:spPr>
               <a:solidFill>
-                <a:srgbClr val="D4AF37"/>
+                <a:srgbClr val="00F0FF"/>
               </a:solidFill>
               <a:ln w="9525" cap="flat">
                 <a:solidFill>
-                  <a:srgbClr val="D4AF37"/>
+                  <a:srgbClr val="00F0FF"/>
                 </a:solidFill>
                 <a:prstDash val="solid"/>
                 <a:round/>
@@ -288,7 +288,7 @@
               <a:pPr>
                 <a:defRPr b="0" i="0" strike="noStrike" sz="1200" u="none">
                   <a:solidFill>
-                    <a:srgbClr val="0A0A0A"/>
+                    <a:srgbClr val="050816"/>
                   </a:solidFill>
                   <a:latin typeface="Arial"/>
                 </a:defRPr>
@@ -335,7 +335,7 @@
             <a:pPr>
               <a:defRPr sz="1200" b="0" i="0" u="none" strike="noStrike">
                 <a:solidFill>
-                  <a:srgbClr val="9CA3AF"/>
+                  <a:srgbClr val="6B7280"/>
                 </a:solidFill>
                 <a:latin typeface="Arial"/>
               </a:defRPr>
@@ -387,7 +387,7 @@
             <a:pPr>
               <a:defRPr sz="1200" b="0" i="0" u="none" strike="noStrike">
                 <a:solidFill>
-                  <a:srgbClr val="9CA3AF"/>
+                  <a:srgbClr val="6B7280"/>
                 </a:solidFill>
                 <a:latin typeface="Arial"/>
               </a:defRPr>
@@ -439,7 +439,7 @@
             <a:pPr>
               <a:defRPr sz="1400" b="0" i="0" u="none" strike="noStrike">
                 <a:solidFill>
-                  <a:srgbClr val="111111"/>
+                  <a:srgbClr val="0A0E27"/>
                 </a:solidFill>
                 <a:latin typeface="Arial"/>
               </a:defRPr>
@@ -447,7 +447,7 @@
             <a:r>
               <a:rPr sz="1400" b="0" i="0" u="none" strike="noStrike">
                 <a:solidFill>
-                  <a:srgbClr val="111111"/>
+                  <a:srgbClr val="0A0E27"/>
                 </a:solidFill>
                 <a:latin typeface="Arial"/>
               </a:rPr>
@@ -496,7 +496,7 @@
             <c:bubble3D val="0"/>
             <c:spPr>
               <a:solidFill>
-                <a:srgbClr val="111111"/>
+                <a:srgbClr val="0A0E27"/>
               </a:solidFill>
               <a:effectLst/>
             </c:spPr>
@@ -506,7 +506,7 @@
             <c:bubble3D val="0"/>
             <c:spPr>
               <a:solidFill>
-                <a:srgbClr val="E5E7EB"/>
+                <a:srgbClr val="E6F1FF"/>
               </a:solidFill>
               <a:effectLst/>
             </c:spPr>
@@ -523,7 +523,7 @@
                   <a:pPr>
                     <a:defRPr sz="1200" b="0" i="0" u="none" strike="noStrike">
                       <a:solidFill>
-                        <a:srgbClr val="F5F5F5"/>
+                        <a:srgbClr val="FFFFFF"/>
                       </a:solidFill>
                       <a:latin typeface="Arial"/>
                     </a:defRPr>
@@ -548,7 +548,7 @@
                   <a:pPr>
                     <a:defRPr sz="1200" b="0" i="0" u="none" strike="noStrike">
                       <a:solidFill>
-                        <a:srgbClr val="F5F5F5"/>
+                        <a:srgbClr val="FFFFFF"/>
                       </a:solidFill>
                       <a:latin typeface="Arial"/>
                     </a:defRPr>
@@ -669,7 +669,7 @@
           </c:tx>
           <c:spPr>
             <a:solidFill>
-              <a:srgbClr val="111111"/>
+              <a:srgbClr val="0A0E27"/>
             </a:solidFill>
             <a:effectLst/>
           </c:spPr>
@@ -683,7 +683,7 @@
                 <a:pPr>
                   <a:defRPr b="0" i="0" strike="noStrike" sz="1200" u="none">
                     <a:solidFill>
-                      <a:srgbClr val="0A0A0A"/>
+                      <a:srgbClr val="050816"/>
                     </a:solidFill>
                     <a:latin typeface="Arial"/>
                   </a:defRPr>
@@ -775,7 +775,7 @@
               <a:pPr>
                 <a:defRPr b="0" i="0" strike="noStrike" sz="1200" u="none">
                   <a:solidFill>
-                    <a:srgbClr val="0A0A0A"/>
+                    <a:srgbClr val="050816"/>
                   </a:solidFill>
                   <a:latin typeface="Arial"/>
                 </a:defRPr>
@@ -823,7 +823,7 @@
             <a:pPr>
               <a:defRPr sz="1300" b="0" i="0" u="none" strike="noStrike">
                 <a:solidFill>
-                  <a:srgbClr val="0A0A0A"/>
+                  <a:srgbClr val="050816"/>
                 </a:solidFill>
                 <a:latin typeface="Arial"/>
               </a:defRPr>
@@ -877,7 +877,7 @@
             <a:pPr>
               <a:defRPr sz="1200" b="0" i="0" u="none" strike="noStrike">
                 <a:solidFill>
-                  <a:srgbClr val="9CA3AF"/>
+                  <a:srgbClr val="6B7280"/>
                 </a:solidFill>
                 <a:latin typeface="Arial"/>
               </a:defRPr>
@@ -2281,7 +2281,7 @@
     <p:bg>
       <p:bgPr>
         <a:solidFill>
-          <a:srgbClr val="111111"/>
+          <a:srgbClr val="0A0E27"/>
         </a:solidFill>
       </p:bgPr>
     </p:bg>
@@ -2314,7 +2314,7 @@
             <a:avLst/>
           </a:prstGeom>
           <a:solidFill>
-            <a:srgbClr val="D4AF37"/>
+            <a:srgbClr val="00F0FF"/>
           </a:solidFill>
           <a:ln/>
         </p:spPr>
@@ -2346,7 +2346,7 @@
             <a:r>
               <a:rPr lang="en-US" sz="6000" b="1" spc="200" kern="0" dirty="0">
                 <a:solidFill>
-                  <a:srgbClr val="F5F5F5"/>
+                  <a:srgbClr val="FFFFFF"/>
                 </a:solidFill>
                 <a:latin typeface="Georgia" pitchFamily="34" charset="0"/>
                 <a:ea typeface="Georgia" pitchFamily="34" charset="-122"/>
@@ -2385,7 +2385,7 @@
             <a:r>
               <a:rPr lang="en-US" sz="2200" dirty="0">
                 <a:solidFill>
-                  <a:srgbClr val="E5E7EB"/>
+                  <a:srgbClr val="E6F1FF"/>
                 </a:solidFill>
                 <a:latin typeface="Calibri" pitchFamily="34" charset="0"/>
                 <a:ea typeface="Calibri" pitchFamily="34" charset="-122"/>
@@ -2412,7 +2412,7 @@
             <a:avLst/>
           </a:prstGeom>
           <a:solidFill>
-            <a:srgbClr val="D4AF37"/>
+            <a:srgbClr val="00F0FF"/>
           </a:solidFill>
           <a:ln/>
         </p:spPr>
@@ -2444,7 +2444,7 @@
             <a:r>
               <a:rPr lang="en-US" sz="1600" dirty="0">
                 <a:solidFill>
-                  <a:srgbClr val="F5F5F5"/>
+                  <a:srgbClr val="FFFFFF"/>
                 </a:solidFill>
               </a:rPr>
               <a:t>IT Operations Manager &amp; Business Analyst  |  Greenville, SC</a:t>
@@ -2480,7 +2480,7 @@
             <a:r>
               <a:rPr lang="en-US" sz="1400" i="1" dirty="0">
                 <a:solidFill>
-                  <a:srgbClr val="D4AF37"/>
+                  <a:srgbClr val="00F0FF"/>
                 </a:solidFill>
               </a:rPr>
               <a:t>Portfolio Deck  •  2026</a:t>
@@ -2503,7 +2503,7 @@
     <p:bg>
       <p:bgPr>
         <a:solidFill>
-          <a:srgbClr val="F5F5F5"/>
+          <a:srgbClr val="FFFFFF"/>
         </a:solidFill>
       </p:bgPr>
     </p:bg>
@@ -2548,7 +2548,7 @@
             <a:r>
               <a:rPr lang="en-US" sz="4000" b="1" dirty="0">
                 <a:solidFill>
-                  <a:srgbClr val="111111"/>
+                  <a:srgbClr val="0A0E27"/>
                 </a:solidFill>
                 <a:latin typeface="Georgia" pitchFamily="34" charset="0"/>
                 <a:ea typeface="Georgia" pitchFamily="34" charset="-122"/>
@@ -2575,7 +2575,7 @@
             <a:avLst/>
           </a:prstGeom>
           <a:solidFill>
-            <a:srgbClr val="E5E7EB"/>
+            <a:srgbClr val="E6F1FF"/>
           </a:solidFill>
           <a:ln/>
         </p:spPr>
@@ -2610,7 +2610,7 @@
             <a:r>
               <a:rPr lang="en-US" sz="1500" dirty="0">
                 <a:solidFill>
-                  <a:srgbClr val="0A0A0A"/>
+                  <a:srgbClr val="050816"/>
                 </a:solidFill>
                 <a:latin typeface="Calibri" pitchFamily="34" charset="0"/>
                 <a:ea typeface="Calibri" pitchFamily="34" charset="-122"/>
@@ -2630,7 +2630,7 @@
             <a:r>
               <a:rPr lang="en-US" sz="1500" dirty="0">
                 <a:solidFill>
-                  <a:srgbClr val="0A0A0A"/>
+                  <a:srgbClr val="050816"/>
                 </a:solidFill>
                 <a:latin typeface="Calibri" pitchFamily="34" charset="0"/>
                 <a:ea typeface="Calibri" pitchFamily="34" charset="-122"/>
@@ -2647,7 +2647,7 @@
             <a:r>
               <a:rPr lang="en-US" sz="1500" dirty="0">
                 <a:solidFill>
-                  <a:srgbClr val="0A0A0A"/>
+                  <a:srgbClr val="050816"/>
                 </a:solidFill>
                 <a:latin typeface="Calibri" pitchFamily="34" charset="0"/>
                 <a:ea typeface="Calibri" pitchFamily="34" charset="-122"/>
@@ -2674,7 +2674,7 @@
             <a:avLst/>
           </a:prstGeom>
           <a:solidFill>
-            <a:srgbClr val="111111"/>
+            <a:srgbClr val="0A0E27"/>
           </a:solidFill>
           <a:ln/>
         </p:spPr>
@@ -2694,7 +2694,7 @@
             <a:avLst/>
           </a:prstGeom>
           <a:solidFill>
-            <a:srgbClr val="D4AF37"/>
+            <a:srgbClr val="00F0FF"/>
           </a:solidFill>
           <a:ln/>
         </p:spPr>
@@ -2726,7 +2726,7 @@
             <a:r>
               <a:rPr lang="en-US" sz="4800" b="1" dirty="0">
                 <a:solidFill>
-                  <a:srgbClr val="F5F5F5"/>
+                  <a:srgbClr val="FFFFFF"/>
                 </a:solidFill>
                 <a:latin typeface="Georgia" pitchFamily="34" charset="0"/>
                 <a:ea typeface="Georgia" pitchFamily="34" charset="-122"/>
@@ -2765,7 +2765,7 @@
             <a:r>
               <a:rPr lang="en-US" sz="1300" dirty="0">
                 <a:solidFill>
-                  <a:srgbClr val="E5E7EB"/>
+                  <a:srgbClr val="E6F1FF"/>
                 </a:solidFill>
               </a:rPr>
               <a:t>Years Experience</a:t>
@@ -2789,7 +2789,7 @@
             <a:avLst/>
           </a:prstGeom>
           <a:solidFill>
-            <a:srgbClr val="111111"/>
+            <a:srgbClr val="0A0E27"/>
           </a:solidFill>
           <a:ln/>
         </p:spPr>
@@ -2809,7 +2809,7 @@
             <a:avLst/>
           </a:prstGeom>
           <a:solidFill>
-            <a:srgbClr val="D4AF37"/>
+            <a:srgbClr val="00F0FF"/>
           </a:solidFill>
           <a:ln/>
         </p:spPr>
@@ -2841,7 +2841,7 @@
             <a:r>
               <a:rPr lang="en-US" sz="4800" b="1" dirty="0">
                 <a:solidFill>
-                  <a:srgbClr val="F5F5F5"/>
+                  <a:srgbClr val="FFFFFF"/>
                 </a:solidFill>
                 <a:latin typeface="Georgia" pitchFamily="34" charset="0"/>
                 <a:ea typeface="Georgia" pitchFamily="34" charset="-122"/>
@@ -2880,7 +2880,7 @@
             <a:r>
               <a:rPr lang="en-US" sz="1300" dirty="0">
                 <a:solidFill>
-                  <a:srgbClr val="E5E7EB"/>
+                  <a:srgbClr val="E6F1FF"/>
                 </a:solidFill>
               </a:rPr>
               <a:t>Months to Full Security Framework</a:t>
@@ -2904,7 +2904,7 @@
             <a:avLst/>
           </a:prstGeom>
           <a:solidFill>
-            <a:srgbClr val="111111"/>
+            <a:srgbClr val="0A0E27"/>
           </a:solidFill>
           <a:ln/>
         </p:spPr>
@@ -2924,7 +2924,7 @@
             <a:avLst/>
           </a:prstGeom>
           <a:solidFill>
-            <a:srgbClr val="D4AF37"/>
+            <a:srgbClr val="00F0FF"/>
           </a:solidFill>
           <a:ln/>
         </p:spPr>
@@ -2956,7 +2956,7 @@
             <a:r>
               <a:rPr lang="en-US" sz="4800" b="1" dirty="0">
                 <a:solidFill>
-                  <a:srgbClr val="F5F5F5"/>
+                  <a:srgbClr val="FFFFFF"/>
                 </a:solidFill>
                 <a:latin typeface="Georgia" pitchFamily="34" charset="0"/>
                 <a:ea typeface="Georgia" pitchFamily="34" charset="-122"/>
@@ -2995,7 +2995,7 @@
             <a:r>
               <a:rPr lang="en-US" sz="1300" dirty="0">
                 <a:solidFill>
-                  <a:srgbClr val="E5E7EB"/>
+                  <a:srgbClr val="E6F1FF"/>
                 </a:solidFill>
               </a:rPr>
               <a:t>Predictive Model Accuracy</a:t>
@@ -3019,7 +3019,7 @@
             <a:avLst/>
           </a:prstGeom>
           <a:solidFill>
-            <a:srgbClr val="111111"/>
+            <a:srgbClr val="0A0E27"/>
           </a:solidFill>
           <a:ln/>
         </p:spPr>
@@ -3039,7 +3039,7 @@
             <a:avLst/>
           </a:prstGeom>
           <a:solidFill>
-            <a:srgbClr val="D4AF37"/>
+            <a:srgbClr val="00F0FF"/>
           </a:solidFill>
           <a:ln/>
         </p:spPr>
@@ -3071,7 +3071,7 @@
             <a:r>
               <a:rPr lang="en-US" sz="4800" b="1" dirty="0">
                 <a:solidFill>
-                  <a:srgbClr val="F5F5F5"/>
+                  <a:srgbClr val="FFFFFF"/>
                 </a:solidFill>
                 <a:latin typeface="Georgia" pitchFamily="34" charset="0"/>
                 <a:ea typeface="Georgia" pitchFamily="34" charset="-122"/>
@@ -3110,7 +3110,7 @@
             <a:r>
               <a:rPr lang="en-US" sz="1300" dirty="0">
                 <a:solidFill>
-                  <a:srgbClr val="E5E7EB"/>
+                  <a:srgbClr val="E6F1FF"/>
                 </a:solidFill>
               </a:rPr>
               <a:t>Clouds (AWS • Azure • GCP)</a:t>
@@ -3134,7 +3134,7 @@
             <a:avLst/>
           </a:prstGeom>
           <a:solidFill>
-            <a:srgbClr val="111111"/>
+            <a:srgbClr val="0A0E27"/>
           </a:solidFill>
           <a:ln/>
         </p:spPr>
@@ -3166,7 +3166,7 @@
             <a:r>
               <a:rPr lang="en-US" sz="1000" dirty="0">
                 <a:solidFill>
-                  <a:srgbClr val="E5E7EB"/>
+                  <a:srgbClr val="E6F1FF"/>
                 </a:solidFill>
               </a:rPr>
               <a:t>Tracey Scott  |  Cybersecurity • Cloud • SOC  |  traceysscott82@gmail.com</a:t>
@@ -3202,7 +3202,7 @@
             <a:r>
               <a:rPr lang="en-US" sz="1000" dirty="0">
                 <a:solidFill>
-                  <a:srgbClr val="E5E7EB"/>
+                  <a:srgbClr val="E6F1FF"/>
                 </a:solidFill>
               </a:rPr>
               <a:t>2</a:t>
@@ -3225,7 +3225,7 @@
     <p:bg>
       <p:bgPr>
         <a:solidFill>
-          <a:srgbClr val="F5F5F5"/>
+          <a:srgbClr val="FFFFFF"/>
         </a:solidFill>
       </p:bgPr>
     </p:bg>
@@ -3270,7 +3270,7 @@
             <a:r>
               <a:rPr lang="en-US" sz="3600" b="1" dirty="0">
                 <a:solidFill>
-                  <a:srgbClr val="111111"/>
+                  <a:srgbClr val="0A0E27"/>
                 </a:solidFill>
                 <a:latin typeface="Georgia" pitchFamily="34" charset="0"/>
                 <a:ea typeface="Georgia" pitchFamily="34" charset="-122"/>
@@ -3297,11 +3297,11 @@
             <a:avLst/>
           </a:prstGeom>
           <a:solidFill>
-            <a:srgbClr val="F5F5F5"/>
+            <a:srgbClr val="FFFFFF"/>
           </a:solidFill>
           <a:ln w="12700">
             <a:solidFill>
-              <a:srgbClr val="E5E7EB"/>
+              <a:srgbClr val="E6F1FF"/>
             </a:solidFill>
             <a:prstDash val="solid"/>
           </a:ln>
@@ -3329,7 +3329,7 @@
             <a:avLst/>
           </a:prstGeom>
           <a:solidFill>
-            <a:srgbClr val="D4AF37"/>
+            <a:srgbClr val="00F0FF"/>
           </a:solidFill>
           <a:ln/>
         </p:spPr>
@@ -3361,7 +3361,7 @@
             <a:r>
               <a:rPr lang="en-US" sz="1800" b="1" dirty="0">
                 <a:solidFill>
-                  <a:srgbClr val="111111"/>
+                  <a:srgbClr val="0A0E27"/>
                 </a:solidFill>
                 <a:latin typeface="Georgia" pitchFamily="34" charset="0"/>
                 <a:ea typeface="Georgia" pitchFamily="34" charset="-122"/>
@@ -3401,7 +3401,7 @@
             <a:r>
               <a:rPr lang="en-US" sz="1300" dirty="0">
                 <a:solidFill>
-                  <a:srgbClr val="0A0A0A"/>
+                  <a:srgbClr val="050816"/>
                 </a:solidFill>
               </a:rPr>
               <a:t>IDS/IPS &amp; Firewall Admin</a:t>
@@ -3416,7 +3416,7 @@
             <a:r>
               <a:rPr lang="en-US" sz="1300" dirty="0">
                 <a:solidFill>
-                  <a:srgbClr val="0A0A0A"/>
+                  <a:srgbClr val="050816"/>
                 </a:solidFill>
               </a:rPr>
               <a:t>Endpoint / EDR &amp; MDM</a:t>
@@ -3431,7 +3431,7 @@
             <a:r>
               <a:rPr lang="en-US" sz="1300" dirty="0">
                 <a:solidFill>
-                  <a:srgbClr val="0A0A0A"/>
+                  <a:srgbClr val="050816"/>
                 </a:solidFill>
               </a:rPr>
               <a:t>Incident Response</a:t>
@@ -3446,7 +3446,7 @@
             <a:r>
               <a:rPr lang="en-US" sz="1300" dirty="0">
                 <a:solidFill>
-                  <a:srgbClr val="0A0A0A"/>
+                  <a:srgbClr val="050816"/>
                 </a:solidFill>
               </a:rPr>
               <a:t>Org Training via KnowBe4</a:t>
@@ -3470,11 +3470,11 @@
             <a:avLst/>
           </a:prstGeom>
           <a:solidFill>
-            <a:srgbClr val="F5F5F5"/>
+            <a:srgbClr val="FFFFFF"/>
           </a:solidFill>
           <a:ln w="12700">
             <a:solidFill>
-              <a:srgbClr val="E5E7EB"/>
+              <a:srgbClr val="E6F1FF"/>
             </a:solidFill>
             <a:prstDash val="solid"/>
           </a:ln>
@@ -3502,7 +3502,7 @@
             <a:avLst/>
           </a:prstGeom>
           <a:solidFill>
-            <a:srgbClr val="D4AF37"/>
+            <a:srgbClr val="00F0FF"/>
           </a:solidFill>
           <a:ln/>
         </p:spPr>
@@ -3534,7 +3534,7 @@
             <a:r>
               <a:rPr lang="en-US" sz="1800" b="1" dirty="0">
                 <a:solidFill>
-                  <a:srgbClr val="111111"/>
+                  <a:srgbClr val="0A0E27"/>
                 </a:solidFill>
                 <a:latin typeface="Georgia" pitchFamily="34" charset="0"/>
                 <a:ea typeface="Georgia" pitchFamily="34" charset="-122"/>
@@ -3574,7 +3574,7 @@
             <a:r>
               <a:rPr lang="en-US" sz="1300" dirty="0">
                 <a:solidFill>
-                  <a:srgbClr val="0A0A0A"/>
+                  <a:srgbClr val="050816"/>
                 </a:solidFill>
               </a:rPr>
               <a:t>AWS, Azure, GCP</a:t>
@@ -3589,7 +3589,7 @@
             <a:r>
               <a:rPr lang="en-US" sz="1300" dirty="0">
                 <a:solidFill>
-                  <a:srgbClr val="0A0A0A"/>
+                  <a:srgbClr val="050816"/>
                 </a:solidFill>
               </a:rPr>
               <a:t>IAM / RBAC / Azure AD</a:t>
@@ -3604,7 +3604,7 @@
             <a:r>
               <a:rPr lang="en-US" sz="1300" dirty="0">
                 <a:solidFill>
-                  <a:srgbClr val="0A0A0A"/>
+                  <a:srgbClr val="050816"/>
                 </a:solidFill>
               </a:rPr>
               <a:t>VMware, Hyper-V, Docker</a:t>
@@ -3619,7 +3619,7 @@
             <a:r>
               <a:rPr lang="en-US" sz="1300" dirty="0">
                 <a:solidFill>
-                  <a:srgbClr val="0A0A0A"/>
+                  <a:srgbClr val="050816"/>
                 </a:solidFill>
               </a:rPr>
               <a:t>M365 &amp; SaaS Admin</a:t>
@@ -3643,11 +3643,11 @@
             <a:avLst/>
           </a:prstGeom>
           <a:solidFill>
-            <a:srgbClr val="F5F5F5"/>
+            <a:srgbClr val="FFFFFF"/>
           </a:solidFill>
           <a:ln w="12700">
             <a:solidFill>
-              <a:srgbClr val="E5E7EB"/>
+              <a:srgbClr val="E6F1FF"/>
             </a:solidFill>
             <a:prstDash val="solid"/>
           </a:ln>
@@ -3675,7 +3675,7 @@
             <a:avLst/>
           </a:prstGeom>
           <a:solidFill>
-            <a:srgbClr val="D4AF37"/>
+            <a:srgbClr val="00F0FF"/>
           </a:solidFill>
           <a:ln/>
         </p:spPr>
@@ -3707,7 +3707,7 @@
             <a:r>
               <a:rPr lang="en-US" sz="1800" b="1" dirty="0">
                 <a:solidFill>
-                  <a:srgbClr val="111111"/>
+                  <a:srgbClr val="0A0E27"/>
                 </a:solidFill>
                 <a:latin typeface="Georgia" pitchFamily="34" charset="0"/>
                 <a:ea typeface="Georgia" pitchFamily="34" charset="-122"/>
@@ -3747,7 +3747,7 @@
             <a:r>
               <a:rPr lang="en-US" sz="1300" dirty="0">
                 <a:solidFill>
-                  <a:srgbClr val="0A0A0A"/>
+                  <a:srgbClr val="050816"/>
                 </a:solidFill>
               </a:rPr>
               <a:t>GDPR, SOX, ITIL</a:t>
@@ -3762,7 +3762,7 @@
             <a:r>
               <a:rPr lang="en-US" sz="1300" dirty="0">
                 <a:solidFill>
-                  <a:srgbClr val="0A0A0A"/>
+                  <a:srgbClr val="050816"/>
                 </a:solidFill>
               </a:rPr>
               <a:t>Risk Assessment</a:t>
@@ -3777,7 +3777,7 @@
             <a:r>
               <a:rPr lang="en-US" sz="1300" dirty="0">
                 <a:solidFill>
-                  <a:srgbClr val="0A0A0A"/>
+                  <a:srgbClr val="050816"/>
                 </a:solidFill>
               </a:rPr>
               <a:t>Vulnerability Management</a:t>
@@ -3792,7 +3792,7 @@
             <a:r>
               <a:rPr lang="en-US" sz="1300" dirty="0">
                 <a:solidFill>
-                  <a:srgbClr val="0A0A0A"/>
+                  <a:srgbClr val="050816"/>
                 </a:solidFill>
               </a:rPr>
               <a:t>Security Policy Design</a:t>
@@ -3816,11 +3816,11 @@
             <a:avLst/>
           </a:prstGeom>
           <a:solidFill>
-            <a:srgbClr val="F5F5F5"/>
+            <a:srgbClr val="FFFFFF"/>
           </a:solidFill>
           <a:ln w="12700">
             <a:solidFill>
-              <a:srgbClr val="E5E7EB"/>
+              <a:srgbClr val="E6F1FF"/>
             </a:solidFill>
             <a:prstDash val="solid"/>
           </a:ln>
@@ -3848,7 +3848,7 @@
             <a:avLst/>
           </a:prstGeom>
           <a:solidFill>
-            <a:srgbClr val="D4AF37"/>
+            <a:srgbClr val="00F0FF"/>
           </a:solidFill>
           <a:ln/>
         </p:spPr>
@@ -3880,7 +3880,7 @@
             <a:r>
               <a:rPr lang="en-US" sz="1800" b="1" dirty="0">
                 <a:solidFill>
-                  <a:srgbClr val="111111"/>
+                  <a:srgbClr val="0A0E27"/>
                 </a:solidFill>
                 <a:latin typeface="Georgia" pitchFamily="34" charset="0"/>
                 <a:ea typeface="Georgia" pitchFamily="34" charset="-122"/>
@@ -3920,7 +3920,7 @@
             <a:r>
               <a:rPr lang="en-US" sz="1300" dirty="0">
                 <a:solidFill>
-                  <a:srgbClr val="0A0A0A"/>
+                  <a:srgbClr val="050816"/>
                 </a:solidFill>
               </a:rPr>
               <a:t>PowerShell, Python, SQL</a:t>
@@ -3935,7 +3935,7 @@
             <a:r>
               <a:rPr lang="en-US" sz="1300" dirty="0">
                 <a:solidFill>
-                  <a:srgbClr val="0A0A0A"/>
+                  <a:srgbClr val="050816"/>
                 </a:solidFill>
               </a:rPr>
               <a:t>Excel (Pivot Tables, VLOOKUP)</a:t>
@@ -3950,7 +3950,7 @@
             <a:r>
               <a:rPr lang="en-US" sz="1300" dirty="0">
                 <a:solidFill>
-                  <a:srgbClr val="0A0A0A"/>
+                  <a:srgbClr val="050816"/>
                 </a:solidFill>
               </a:rPr>
               <a:t>Power BI, Tableau &amp; LLMs</a:t>
@@ -3965,7 +3965,7 @@
             <a:r>
               <a:rPr lang="en-US" sz="1300" dirty="0">
                 <a:solidFill>
-                  <a:srgbClr val="0A0A0A"/>
+                  <a:srgbClr val="050816"/>
                 </a:solidFill>
               </a:rPr>
               <a:t>Predictive Modeling &amp; Automation</a:t>
@@ -3989,7 +3989,7 @@
             <a:avLst/>
           </a:prstGeom>
           <a:solidFill>
-            <a:srgbClr val="111111"/>
+            <a:srgbClr val="0A0E27"/>
           </a:solidFill>
           <a:ln/>
         </p:spPr>
@@ -4021,7 +4021,7 @@
             <a:r>
               <a:rPr lang="en-US" sz="1000" dirty="0">
                 <a:solidFill>
-                  <a:srgbClr val="E5E7EB"/>
+                  <a:srgbClr val="E6F1FF"/>
                 </a:solidFill>
               </a:rPr>
               <a:t>Tracey Scott  |  Cybersecurity • Cloud • SOC  |  traceysscott82@gmail.com</a:t>
@@ -4057,7 +4057,7 @@
             <a:r>
               <a:rPr lang="en-US" sz="1000" dirty="0">
                 <a:solidFill>
-                  <a:srgbClr val="E5E7EB"/>
+                  <a:srgbClr val="E6F1FF"/>
                 </a:solidFill>
               </a:rPr>
               <a:t>3</a:t>
@@ -4080,7 +4080,7 @@
     <p:bg>
       <p:bgPr>
         <a:solidFill>
-          <a:srgbClr val="F5F5F5"/>
+          <a:srgbClr val="FFFFFF"/>
         </a:solidFill>
       </p:bgPr>
     </p:bg>
@@ -4125,7 +4125,7 @@
             <a:r>
               <a:rPr lang="en-US" sz="3600" b="1" dirty="0">
                 <a:solidFill>
-                  <a:srgbClr val="111111"/>
+                  <a:srgbClr val="0A0E27"/>
                 </a:solidFill>
                 <a:latin typeface="Georgia" pitchFamily="34" charset="0"/>
                 <a:ea typeface="Georgia" pitchFamily="34" charset="-122"/>
@@ -4164,7 +4164,7 @@
             <a:r>
               <a:rPr lang="en-US" sz="1400" i="1" dirty="0">
                 <a:solidFill>
-                  <a:srgbClr val="9CA3AF"/>
+                  <a:srgbClr val="6B7280"/>
                 </a:solidFill>
               </a:rPr>
               <a:t>Executive view I built at RightPath to monitor posture, incidents, and compliance.</a:t>
@@ -4188,7 +4188,7 @@
             <a:avLst/>
           </a:prstGeom>
           <a:solidFill>
-            <a:srgbClr val="111111"/>
+            <a:srgbClr val="0A0E27"/>
           </a:solidFill>
           <a:ln/>
         </p:spPr>
@@ -4220,7 +4220,7 @@
             <a:r>
               <a:rPr lang="en-US" sz="3000" b="1" dirty="0">
                 <a:solidFill>
-                  <a:srgbClr val="D4AF37"/>
+                  <a:srgbClr val="00F0FF"/>
                 </a:solidFill>
                 <a:latin typeface="Georgia" pitchFamily="34" charset="0"/>
                 <a:ea typeface="Georgia" pitchFamily="34" charset="-122"/>
@@ -4259,7 +4259,7 @@
             <a:r>
               <a:rPr lang="en-US" sz="1200" dirty="0">
                 <a:solidFill>
-                  <a:srgbClr val="E5E7EB"/>
+                  <a:srgbClr val="E6F1FF"/>
                 </a:solidFill>
               </a:rPr>
               <a:t>Uptime</a:t>
@@ -4283,7 +4283,7 @@
             <a:avLst/>
           </a:prstGeom>
           <a:solidFill>
-            <a:srgbClr val="111111"/>
+            <a:srgbClr val="0A0E27"/>
           </a:solidFill>
           <a:ln/>
         </p:spPr>
@@ -4315,7 +4315,7 @@
             <a:r>
               <a:rPr lang="en-US" sz="3000" b="1" dirty="0">
                 <a:solidFill>
-                  <a:srgbClr val="D4AF37"/>
+                  <a:srgbClr val="00F0FF"/>
                 </a:solidFill>
                 <a:latin typeface="Georgia" pitchFamily="34" charset="0"/>
                 <a:ea typeface="Georgia" pitchFamily="34" charset="-122"/>
@@ -4354,7 +4354,7 @@
             <a:r>
               <a:rPr lang="en-US" sz="1200" dirty="0">
                 <a:solidFill>
-                  <a:srgbClr val="E5E7EB"/>
+                  <a:srgbClr val="E6F1FF"/>
                 </a:solidFill>
               </a:rPr>
               <a:t>Critical Breaches</a:t>
@@ -4378,7 +4378,7 @@
             <a:avLst/>
           </a:prstGeom>
           <a:solidFill>
-            <a:srgbClr val="111111"/>
+            <a:srgbClr val="0A0E27"/>
           </a:solidFill>
           <a:ln/>
         </p:spPr>
@@ -4410,7 +4410,7 @@
             <a:r>
               <a:rPr lang="en-US" sz="3000" b="1" dirty="0">
                 <a:solidFill>
-                  <a:srgbClr val="D4AF37"/>
+                  <a:srgbClr val="00F0FF"/>
                 </a:solidFill>
                 <a:latin typeface="Georgia" pitchFamily="34" charset="0"/>
                 <a:ea typeface="Georgia" pitchFamily="34" charset="-122"/>
@@ -4449,7 +4449,7 @@
             <a:r>
               <a:rPr lang="en-US" sz="1200" dirty="0">
                 <a:solidFill>
-                  <a:srgbClr val="E5E7EB"/>
+                  <a:srgbClr val="E6F1FF"/>
                 </a:solidFill>
               </a:rPr>
               <a:t>Threats Mitigated</a:t>
@@ -4473,7 +4473,7 @@
             <a:avLst/>
           </a:prstGeom>
           <a:solidFill>
-            <a:srgbClr val="111111"/>
+            <a:srgbClr val="0A0E27"/>
           </a:solidFill>
           <a:ln/>
         </p:spPr>
@@ -4505,7 +4505,7 @@
             <a:r>
               <a:rPr lang="en-US" sz="3000" b="1" dirty="0">
                 <a:solidFill>
-                  <a:srgbClr val="D4AF37"/>
+                  <a:srgbClr val="00F0FF"/>
                 </a:solidFill>
                 <a:latin typeface="Georgia" pitchFamily="34" charset="0"/>
                 <a:ea typeface="Georgia" pitchFamily="34" charset="-122"/>
@@ -4544,7 +4544,7 @@
             <a:r>
               <a:rPr lang="en-US" sz="1200" dirty="0">
                 <a:solidFill>
-                  <a:srgbClr val="E5E7EB"/>
+                  <a:srgbClr val="E6F1FF"/>
                 </a:solidFill>
               </a:rPr>
               <a:t>RBAC Coverage</a:t>
@@ -4600,7 +4600,7 @@
             <a:avLst/>
           </a:prstGeom>
           <a:solidFill>
-            <a:srgbClr val="111111"/>
+            <a:srgbClr val="0A0E27"/>
           </a:solidFill>
           <a:ln/>
         </p:spPr>
@@ -4632,7 +4632,7 @@
             <a:r>
               <a:rPr lang="en-US" sz="1000" dirty="0">
                 <a:solidFill>
-                  <a:srgbClr val="E5E7EB"/>
+                  <a:srgbClr val="E6F1FF"/>
                 </a:solidFill>
               </a:rPr>
               <a:t>Tracey Scott  |  Cybersecurity • Cloud • SOC  |  traceysscott82@gmail.com</a:t>
@@ -4668,7 +4668,7 @@
             <a:r>
               <a:rPr lang="en-US" sz="1000" dirty="0">
                 <a:solidFill>
-                  <a:srgbClr val="E5E7EB"/>
+                  <a:srgbClr val="E6F1FF"/>
                 </a:solidFill>
               </a:rPr>
               <a:t>4</a:t>
@@ -4691,7 +4691,7 @@
     <p:bg>
       <p:bgPr>
         <a:solidFill>
-          <a:srgbClr val="F5F5F5"/>
+          <a:srgbClr val="FFFFFF"/>
         </a:solidFill>
       </p:bgPr>
     </p:bg>
@@ -4736,7 +4736,7 @@
             <a:r>
               <a:rPr lang="en-US" sz="3600" b="1" dirty="0">
                 <a:solidFill>
-                  <a:srgbClr val="111111"/>
+                  <a:srgbClr val="0A0E27"/>
                 </a:solidFill>
                 <a:latin typeface="Georgia" pitchFamily="34" charset="0"/>
                 <a:ea typeface="Georgia" pitchFamily="34" charset="-122"/>
@@ -4763,7 +4763,7 @@
             <a:avLst/>
           </a:prstGeom>
           <a:solidFill>
-            <a:srgbClr val="E5E7EB"/>
+            <a:srgbClr val="E6F1FF"/>
           </a:solidFill>
           <a:ln/>
         </p:spPr>
@@ -4783,7 +4783,7 @@
             <a:avLst/>
           </a:prstGeom>
           <a:solidFill>
-            <a:srgbClr val="D4AF37"/>
+            <a:srgbClr val="00F0FF"/>
           </a:solidFill>
           <a:ln/>
         </p:spPr>
@@ -4815,7 +4815,7 @@
             <a:r>
               <a:rPr lang="en-US" sz="1300" b="1" dirty="0">
                 <a:solidFill>
-                  <a:srgbClr val="D4AF37"/>
+                  <a:srgbClr val="00F0FF"/>
                 </a:solidFill>
                 <a:latin typeface="Georgia" pitchFamily="34" charset="0"/>
                 <a:ea typeface="Georgia" pitchFamily="34" charset="-122"/>
@@ -4854,7 +4854,7 @@
             <a:r>
               <a:rPr lang="en-US" sz="1400" b="1" dirty="0">
                 <a:solidFill>
-                  <a:srgbClr val="111111"/>
+                  <a:srgbClr val="0A0E27"/>
                 </a:solidFill>
               </a:rPr>
               <a:t>Enterprise Security Framework</a:t>
@@ -4890,7 +4890,7 @@
             <a:r>
               <a:rPr lang="en-US" sz="1100" dirty="0">
                 <a:solidFill>
-                  <a:srgbClr val="0A0A0A"/>
+                  <a:srgbClr val="050816"/>
                 </a:solidFill>
               </a:rPr>
               <a:t>Architected endpoint, IDS/IPS, MDM, and access governance for startup in 6 months.</a:t>
@@ -4914,7 +4914,7 @@
             <a:avLst/>
           </a:prstGeom>
           <a:solidFill>
-            <a:srgbClr val="E5E7EB"/>
+            <a:srgbClr val="E6F1FF"/>
           </a:solidFill>
           <a:ln/>
         </p:spPr>
@@ -4934,7 +4934,7 @@
             <a:avLst/>
           </a:prstGeom>
           <a:solidFill>
-            <a:srgbClr val="D4AF37"/>
+            <a:srgbClr val="00F0FF"/>
           </a:solidFill>
           <a:ln/>
         </p:spPr>
@@ -4966,7 +4966,7 @@
             <a:r>
               <a:rPr lang="en-US" sz="1300" b="1" dirty="0">
                 <a:solidFill>
-                  <a:srgbClr val="D4AF37"/>
+                  <a:srgbClr val="00F0FF"/>
                 </a:solidFill>
                 <a:latin typeface="Georgia" pitchFamily="34" charset="0"/>
                 <a:ea typeface="Georgia" pitchFamily="34" charset="-122"/>
@@ -5005,7 +5005,7 @@
             <a:r>
               <a:rPr lang="en-US" sz="1400" b="1" dirty="0">
                 <a:solidFill>
-                  <a:srgbClr val="111111"/>
+                  <a:srgbClr val="0A0E27"/>
                 </a:solidFill>
               </a:rPr>
               <a:t>Secure Multi-Cloud Deployment</a:t>
@@ -5041,7 +5041,7 @@
             <a:r>
               <a:rPr lang="en-US" sz="1100" dirty="0">
                 <a:solidFill>
-                  <a:srgbClr val="0A0A0A"/>
+                  <a:srgbClr val="050816"/>
                 </a:solidFill>
               </a:rPr>
               <a:t>AWS + Azure infrastructure with IAM, RBAC, encryption, and least-privilege controls.</a:t>
@@ -5065,7 +5065,7 @@
             <a:avLst/>
           </a:prstGeom>
           <a:solidFill>
-            <a:srgbClr val="E5E7EB"/>
+            <a:srgbClr val="E6F1FF"/>
           </a:solidFill>
           <a:ln/>
         </p:spPr>
@@ -5085,7 +5085,7 @@
             <a:avLst/>
           </a:prstGeom>
           <a:solidFill>
-            <a:srgbClr val="D4AF37"/>
+            <a:srgbClr val="00F0FF"/>
           </a:solidFill>
           <a:ln/>
         </p:spPr>
@@ -5117,7 +5117,7 @@
             <a:r>
               <a:rPr lang="en-US" sz="1300" b="1" dirty="0">
                 <a:solidFill>
-                  <a:srgbClr val="D4AF37"/>
+                  <a:srgbClr val="00F0FF"/>
                 </a:solidFill>
                 <a:latin typeface="Georgia" pitchFamily="34" charset="0"/>
                 <a:ea typeface="Georgia" pitchFamily="34" charset="-122"/>
@@ -5156,7 +5156,7 @@
             <a:r>
               <a:rPr lang="en-US" sz="1400" b="1" dirty="0">
                 <a:solidFill>
-                  <a:srgbClr val="111111"/>
+                  <a:srgbClr val="0A0E27"/>
                 </a:solidFill>
               </a:rPr>
               <a:t>CRM Secure Deployment</a:t>
@@ -5192,7 +5192,7 @@
             <a:r>
               <a:rPr lang="en-US" sz="1100" dirty="0">
                 <a:solidFill>
-                  <a:srgbClr val="0A0A0A"/>
+                  <a:srgbClr val="050816"/>
                 </a:solidFill>
               </a:rPr>
               <a:t>Complete CRM build — coding, development, maintenance, secure auth, encryption, RBAC.</a:t>
@@ -5216,7 +5216,7 @@
             <a:avLst/>
           </a:prstGeom>
           <a:solidFill>
-            <a:srgbClr val="E5E7EB"/>
+            <a:srgbClr val="E6F1FF"/>
           </a:solidFill>
           <a:ln/>
         </p:spPr>
@@ -5236,7 +5236,7 @@
             <a:avLst/>
           </a:prstGeom>
           <a:solidFill>
-            <a:srgbClr val="D4AF37"/>
+            <a:srgbClr val="00F0FF"/>
           </a:solidFill>
           <a:ln/>
         </p:spPr>
@@ -5268,7 +5268,7 @@
             <a:r>
               <a:rPr lang="en-US" sz="1300" b="1" dirty="0">
                 <a:solidFill>
-                  <a:srgbClr val="D4AF37"/>
+                  <a:srgbClr val="00F0FF"/>
                 </a:solidFill>
                 <a:latin typeface="Georgia" pitchFamily="34" charset="0"/>
                 <a:ea typeface="Georgia" pitchFamily="34" charset="-122"/>
@@ -5307,7 +5307,7 @@
             <a:r>
               <a:rPr lang="en-US" sz="1400" b="1" dirty="0">
                 <a:solidFill>
-                  <a:srgbClr val="111111"/>
+                  <a:srgbClr val="0A0E27"/>
                 </a:solidFill>
               </a:rPr>
               <a:t>Executive Dashboards</a:t>
@@ -5343,7 +5343,7 @@
             <a:r>
               <a:rPr lang="en-US" sz="1100" dirty="0">
                 <a:solidFill>
-                  <a:srgbClr val="0A0A0A"/>
+                  <a:srgbClr val="050816"/>
                 </a:solidFill>
               </a:rPr>
               <a:t>Power BI dashboards for incidents, compliance, and sales metrics — auditing, trends &amp; revenue forecasting.</a:t>
@@ -5367,7 +5367,7 @@
             <a:avLst/>
           </a:prstGeom>
           <a:solidFill>
-            <a:srgbClr val="E5E7EB"/>
+            <a:srgbClr val="E6F1FF"/>
           </a:solidFill>
           <a:ln/>
         </p:spPr>
@@ -5387,7 +5387,7 @@
             <a:avLst/>
           </a:prstGeom>
           <a:solidFill>
-            <a:srgbClr val="D4AF37"/>
+            <a:srgbClr val="00F0FF"/>
           </a:solidFill>
           <a:ln/>
         </p:spPr>
@@ -5419,7 +5419,7 @@
             <a:r>
               <a:rPr lang="en-US" sz="1300" b="1" dirty="0">
                 <a:solidFill>
-                  <a:srgbClr val="D4AF37"/>
+                  <a:srgbClr val="00F0FF"/>
                 </a:solidFill>
                 <a:latin typeface="Georgia" pitchFamily="34" charset="0"/>
                 <a:ea typeface="Georgia" pitchFamily="34" charset="-122"/>
@@ -5458,7 +5458,7 @@
             <a:r>
               <a:rPr lang="en-US" sz="1400" b="1" dirty="0">
                 <a:solidFill>
-                  <a:srgbClr val="111111"/>
+                  <a:srgbClr val="0A0E27"/>
                 </a:solidFill>
               </a:rPr>
               <a:t>Incident Response &amp; KnowBe4</a:t>
@@ -5494,7 +5494,7 @@
             <a:r>
               <a:rPr lang="en-US" sz="1100" dirty="0">
                 <a:solidFill>
-                  <a:srgbClr val="0A0A0A"/>
+                  <a:srgbClr val="050816"/>
                 </a:solidFill>
               </a:rPr>
               <a:t>IR playbooks, remediation workflows, and org-wide KnowBe4 security awareness training.</a:t>
@@ -5518,7 +5518,7 @@
             <a:avLst/>
           </a:prstGeom>
           <a:solidFill>
-            <a:srgbClr val="E5E7EB"/>
+            <a:srgbClr val="E6F1FF"/>
           </a:solidFill>
           <a:ln/>
         </p:spPr>
@@ -5538,7 +5538,7 @@
             <a:avLst/>
           </a:prstGeom>
           <a:solidFill>
-            <a:srgbClr val="D4AF37"/>
+            <a:srgbClr val="00F0FF"/>
           </a:solidFill>
           <a:ln/>
         </p:spPr>
@@ -5570,7 +5570,7 @@
             <a:r>
               <a:rPr lang="en-US" sz="1300" b="1" dirty="0">
                 <a:solidFill>
-                  <a:srgbClr val="D4AF37"/>
+                  <a:srgbClr val="00F0FF"/>
                 </a:solidFill>
                 <a:latin typeface="Georgia" pitchFamily="34" charset="0"/>
                 <a:ea typeface="Georgia" pitchFamily="34" charset="-122"/>
@@ -5609,7 +5609,7 @@
             <a:r>
               <a:rPr lang="en-US" sz="1400" b="1" dirty="0">
                 <a:solidFill>
-                  <a:srgbClr val="111111"/>
+                  <a:srgbClr val="0A0E27"/>
                 </a:solidFill>
               </a:rPr>
               <a:t>IT Ticketing System</a:t>
@@ -5645,7 +5645,7 @@
             <a:r>
               <a:rPr lang="en-US" sz="1100" dirty="0">
                 <a:solidFill>
-                  <a:srgbClr val="0A0A0A"/>
+                  <a:srgbClr val="050816"/>
                 </a:solidFill>
               </a:rPr>
               <a:t>Built ticketing system for org-wide issue reporting, triage, and resolution tracking.</a:t>
@@ -5669,7 +5669,7 @@
             <a:avLst/>
           </a:prstGeom>
           <a:solidFill>
-            <a:srgbClr val="E5E7EB"/>
+            <a:srgbClr val="E6F1FF"/>
           </a:solidFill>
           <a:ln/>
         </p:spPr>
@@ -5689,7 +5689,7 @@
             <a:avLst/>
           </a:prstGeom>
           <a:solidFill>
-            <a:srgbClr val="D4AF37"/>
+            <a:srgbClr val="00F0FF"/>
           </a:solidFill>
           <a:ln/>
         </p:spPr>
@@ -5721,7 +5721,7 @@
             <a:r>
               <a:rPr lang="en-US" sz="1300" b="1" dirty="0">
                 <a:solidFill>
-                  <a:srgbClr val="D4AF37"/>
+                  <a:srgbClr val="00F0FF"/>
                 </a:solidFill>
                 <a:latin typeface="Georgia" pitchFamily="34" charset="0"/>
                 <a:ea typeface="Georgia" pitchFamily="34" charset="-122"/>
@@ -5760,7 +5760,7 @@
             <a:r>
               <a:rPr lang="en-US" sz="1400" b="1" dirty="0">
                 <a:solidFill>
-                  <a:srgbClr val="111111"/>
+                  <a:srgbClr val="0A0E27"/>
                 </a:solidFill>
               </a:rPr>
               <a:t>Internal AI Chatbots (LLM)</a:t>
@@ -5796,7 +5796,7 @@
             <a:r>
               <a:rPr lang="en-US" sz="1100" dirty="0">
                 <a:solidFill>
-                  <a:srgbClr val="0A0A0A"/>
+                  <a:srgbClr val="050816"/>
                 </a:solidFill>
               </a:rPr>
               <a:t>LLM-powered chatbots for multiple departments with CRM, Microsoft 365, and SharePoint connectivity.</a:t>
@@ -5820,7 +5820,7 @@
             <a:avLst/>
           </a:prstGeom>
           <a:solidFill>
-            <a:srgbClr val="111111"/>
+            <a:srgbClr val="0A0E27"/>
           </a:solidFill>
           <a:ln/>
         </p:spPr>
@@ -5852,7 +5852,7 @@
             <a:r>
               <a:rPr lang="en-US" sz="1000" dirty="0">
                 <a:solidFill>
-                  <a:srgbClr val="E5E7EB"/>
+                  <a:srgbClr val="E6F1FF"/>
                 </a:solidFill>
               </a:rPr>
               <a:t>Tracey Scott  |  Cybersecurity • Cloud • SOC  |  traceysscott82@gmail.com</a:t>
@@ -5888,7 +5888,7 @@
             <a:r>
               <a:rPr lang="en-US" sz="1000" dirty="0">
                 <a:solidFill>
-                  <a:srgbClr val="E5E7EB"/>
+                  <a:srgbClr val="E6F1FF"/>
                 </a:solidFill>
               </a:rPr>
               <a:t>5</a:t>
@@ -5911,7 +5911,7 @@
     <p:bg>
       <p:bgPr>
         <a:solidFill>
-          <a:srgbClr val="F5F5F5"/>
+          <a:srgbClr val="FFFFFF"/>
         </a:solidFill>
       </p:bgPr>
     </p:bg>
@@ -5956,7 +5956,7 @@
             <a:r>
               <a:rPr lang="en-US" sz="3600" b="1" dirty="0">
                 <a:solidFill>
-                  <a:srgbClr val="111111"/>
+                  <a:srgbClr val="0A0E27"/>
                 </a:solidFill>
                 <a:latin typeface="Georgia" pitchFamily="34" charset="0"/>
                 <a:ea typeface="Georgia" pitchFamily="34" charset="-122"/>
@@ -5995,7 +5995,7 @@
             <a:r>
               <a:rPr lang="en-US" sz="1400" i="1" dirty="0">
                 <a:solidFill>
-                  <a:srgbClr val="9CA3AF"/>
+                  <a:srgbClr val="6B7280"/>
                 </a:solidFill>
               </a:rPr>
               <a:t>Self-assessed proficiency across the stack I use in production.</a:t>
@@ -6035,7 +6035,7 @@
             <a:avLst/>
           </a:prstGeom>
           <a:solidFill>
-            <a:srgbClr val="111111"/>
+            <a:srgbClr val="0A0E27"/>
           </a:solidFill>
           <a:ln/>
         </p:spPr>
@@ -6067,7 +6067,7 @@
             <a:r>
               <a:rPr lang="en-US" sz="1000" dirty="0">
                 <a:solidFill>
-                  <a:srgbClr val="E5E7EB"/>
+                  <a:srgbClr val="E6F1FF"/>
                 </a:solidFill>
               </a:rPr>
               <a:t>Tracey Scott  |  Cybersecurity • Cloud • SOC  |  traceysscott82@gmail.com</a:t>
@@ -6103,7 +6103,7 @@
             <a:r>
               <a:rPr lang="en-US" sz="1000" dirty="0">
                 <a:solidFill>
-                  <a:srgbClr val="E5E7EB"/>
+                  <a:srgbClr val="E6F1FF"/>
                 </a:solidFill>
               </a:rPr>
               <a:t>6</a:t>
@@ -6126,7 +6126,7 @@
     <p:bg>
       <p:bgPr>
         <a:solidFill>
-          <a:srgbClr val="111111"/>
+          <a:srgbClr val="0A0E27"/>
         </a:solidFill>
       </p:bgPr>
     </p:bg>
@@ -6171,7 +6171,7 @@
             <a:r>
               <a:rPr lang="en-US" sz="3600" b="1" dirty="0">
                 <a:solidFill>
-                  <a:srgbClr val="F5F5F5"/>
+                  <a:srgbClr val="FFFFFF"/>
                 </a:solidFill>
                 <a:latin typeface="Georgia" pitchFamily="34" charset="0"/>
                 <a:ea typeface="Georgia" pitchFamily="34" charset="-122"/>
@@ -6198,7 +6198,7 @@
             <a:avLst/>
           </a:prstGeom>
           <a:solidFill>
-            <a:srgbClr val="D4AF37"/>
+            <a:srgbClr val="00F0FF"/>
           </a:solidFill>
           <a:ln/>
         </p:spPr>
@@ -6218,13 +6218,13 @@
             <a:avLst/>
           </a:prstGeom>
           <a:solidFill>
-            <a:srgbClr val="F5F5F5">
+            <a:srgbClr val="FFFFFF">
               <a:alpha val="10000"/>
             </a:srgbClr>
           </a:solidFill>
           <a:ln w="12700">
             <a:solidFill>
-              <a:srgbClr val="E5E7EB"/>
+              <a:srgbClr val="E6F1FF"/>
             </a:solidFill>
             <a:prstDash val="solid"/>
           </a:ln>
@@ -6257,7 +6257,7 @@
             <a:r>
               <a:rPr lang="en-US" sz="4400" b="1" dirty="0">
                 <a:solidFill>
-                  <a:srgbClr val="D4AF37"/>
+                  <a:srgbClr val="00F0FF"/>
                 </a:solidFill>
                 <a:latin typeface="Georgia" pitchFamily="34" charset="0"/>
                 <a:ea typeface="Georgia" pitchFamily="34" charset="-122"/>
@@ -6296,7 +6296,7 @@
             <a:r>
               <a:rPr lang="en-US" sz="1300" dirty="0">
                 <a:solidFill>
-                  <a:srgbClr val="F5F5F5"/>
+                  <a:srgbClr val="FFFFFF"/>
                 </a:solidFill>
               </a:rPr>
               <a:t>Full security framework stood up from zero</a:t>
@@ -6320,13 +6320,13 @@
             <a:avLst/>
           </a:prstGeom>
           <a:solidFill>
-            <a:srgbClr val="F5F5F5">
+            <a:srgbClr val="FFFFFF">
               <a:alpha val="10000"/>
             </a:srgbClr>
           </a:solidFill>
           <a:ln w="12700">
             <a:solidFill>
-              <a:srgbClr val="E5E7EB"/>
+              <a:srgbClr val="E6F1FF"/>
             </a:solidFill>
             <a:prstDash val="solid"/>
           </a:ln>
@@ -6359,7 +6359,7 @@
             <a:r>
               <a:rPr lang="en-US" sz="4400" b="1" dirty="0">
                 <a:solidFill>
-                  <a:srgbClr val="D4AF37"/>
+                  <a:srgbClr val="00F0FF"/>
                 </a:solidFill>
                 <a:latin typeface="Georgia" pitchFamily="34" charset="0"/>
                 <a:ea typeface="Georgia" pitchFamily="34" charset="-122"/>
@@ -6398,7 +6398,7 @@
             <a:r>
               <a:rPr lang="en-US" sz="1300" dirty="0">
                 <a:solidFill>
-                  <a:srgbClr val="F5F5F5"/>
+                  <a:srgbClr val="FFFFFF"/>
                 </a:solidFill>
               </a:rPr>
               <a:t>Predictive model accuracy delivered to stakeholders</a:t>
@@ -6422,13 +6422,13 @@
             <a:avLst/>
           </a:prstGeom>
           <a:solidFill>
-            <a:srgbClr val="F5F5F5">
+            <a:srgbClr val="FFFFFF">
               <a:alpha val="10000"/>
             </a:srgbClr>
           </a:solidFill>
           <a:ln w="12700">
             <a:solidFill>
-              <a:srgbClr val="E5E7EB"/>
+              <a:srgbClr val="E6F1FF"/>
             </a:solidFill>
             <a:prstDash val="solid"/>
           </a:ln>
@@ -6461,7 +6461,7 @@
             <a:r>
               <a:rPr lang="en-US" sz="4400" b="1" dirty="0">
                 <a:solidFill>
-                  <a:srgbClr val="D4AF37"/>
+                  <a:srgbClr val="00F0FF"/>
                 </a:solidFill>
                 <a:latin typeface="Georgia" pitchFamily="34" charset="0"/>
                 <a:ea typeface="Georgia" pitchFamily="34" charset="-122"/>
@@ -6500,7 +6500,7 @@
             <a:r>
               <a:rPr lang="en-US" sz="1300" dirty="0">
                 <a:solidFill>
-                  <a:srgbClr val="F5F5F5"/>
+                  <a:srgbClr val="FFFFFF"/>
                 </a:solidFill>
               </a:rPr>
               <a:t>Reporting accuracy gain through data validation</a:t>
@@ -6524,13 +6524,13 @@
             <a:avLst/>
           </a:prstGeom>
           <a:solidFill>
-            <a:srgbClr val="F5F5F5">
+            <a:srgbClr val="FFFFFF">
               <a:alpha val="10000"/>
             </a:srgbClr>
           </a:solidFill>
           <a:ln w="12700">
             <a:solidFill>
-              <a:srgbClr val="E5E7EB"/>
+              <a:srgbClr val="E6F1FF"/>
             </a:solidFill>
             <a:prstDash val="solid"/>
           </a:ln>
@@ -6563,7 +6563,7 @@
             <a:r>
               <a:rPr lang="en-US" sz="4400" b="1" dirty="0">
                 <a:solidFill>
-                  <a:srgbClr val="D4AF37"/>
+                  <a:srgbClr val="00F0FF"/>
                 </a:solidFill>
                 <a:latin typeface="Georgia" pitchFamily="34" charset="0"/>
                 <a:ea typeface="Georgia" pitchFamily="34" charset="-122"/>
@@ -6602,7 +6602,7 @@
             <a:r>
               <a:rPr lang="en-US" sz="1300" dirty="0">
                 <a:solidFill>
-                  <a:srgbClr val="F5F5F5"/>
+                  <a:srgbClr val="FFFFFF"/>
                 </a:solidFill>
               </a:rPr>
               <a:t>RBAC / least-privilege coverage across hybrid env</a:t>
@@ -6626,13 +6626,13 @@
             <a:avLst/>
           </a:prstGeom>
           <a:solidFill>
-            <a:srgbClr val="F5F5F5">
+            <a:srgbClr val="FFFFFF">
               <a:alpha val="10000"/>
             </a:srgbClr>
           </a:solidFill>
           <a:ln w="12700">
             <a:solidFill>
-              <a:srgbClr val="E5E7EB"/>
+              <a:srgbClr val="E6F1FF"/>
             </a:solidFill>
             <a:prstDash val="solid"/>
           </a:ln>
@@ -6665,7 +6665,7 @@
             <a:r>
               <a:rPr lang="en-US" sz="4400" b="1" dirty="0">
                 <a:solidFill>
-                  <a:srgbClr val="D4AF37"/>
+                  <a:srgbClr val="00F0FF"/>
                 </a:solidFill>
                 <a:latin typeface="Georgia" pitchFamily="34" charset="0"/>
                 <a:ea typeface="Georgia" pitchFamily="34" charset="-122"/>
@@ -6704,7 +6704,7 @@
             <a:r>
               <a:rPr lang="en-US" sz="1300" dirty="0">
                 <a:solidFill>
-                  <a:srgbClr val="F5F5F5"/>
+                  <a:srgbClr val="FFFFFF"/>
                 </a:solidFill>
               </a:rPr>
               <a:t>Critical incidents since framework rollout</a:t>
@@ -6728,13 +6728,13 @@
             <a:avLst/>
           </a:prstGeom>
           <a:solidFill>
-            <a:srgbClr val="F5F5F5">
+            <a:srgbClr val="FFFFFF">
               <a:alpha val="10000"/>
             </a:srgbClr>
           </a:solidFill>
           <a:ln w="12700">
             <a:solidFill>
-              <a:srgbClr val="E5E7EB"/>
+              <a:srgbClr val="E6F1FF"/>
             </a:solidFill>
             <a:prstDash val="solid"/>
           </a:ln>
@@ -6767,7 +6767,7 @@
             <a:r>
               <a:rPr lang="en-US" sz="4400" b="1" dirty="0">
                 <a:solidFill>
-                  <a:srgbClr val="D4AF37"/>
+                  <a:srgbClr val="00F0FF"/>
                 </a:solidFill>
                 <a:latin typeface="Georgia" pitchFamily="34" charset="0"/>
                 <a:ea typeface="Georgia" pitchFamily="34" charset="-122"/>
@@ -6806,7 +6806,7 @@
             <a:r>
               <a:rPr lang="en-US" sz="1300" dirty="0">
                 <a:solidFill>
-                  <a:srgbClr val="F5F5F5"/>
+                  <a:srgbClr val="FFFFFF"/>
                 </a:solidFill>
               </a:rPr>
               <a:t>Public clouds secured and administered (AWS/Azure/GCP)</a:t>
@@ -6830,7 +6830,7 @@
             <a:avLst/>
           </a:prstGeom>
           <a:solidFill>
-            <a:srgbClr val="111111"/>
+            <a:srgbClr val="0A0E27"/>
           </a:solidFill>
           <a:ln/>
         </p:spPr>
@@ -6862,7 +6862,7 @@
             <a:r>
               <a:rPr lang="en-US" sz="1000" dirty="0">
                 <a:solidFill>
-                  <a:srgbClr val="E5E7EB"/>
+                  <a:srgbClr val="E6F1FF"/>
                 </a:solidFill>
               </a:rPr>
               <a:t>Tracey Scott  |  Cybersecurity • Cloud • SOC  |  traceysscott82@gmail.com</a:t>
@@ -6898,7 +6898,7 @@
             <a:r>
               <a:rPr lang="en-US" sz="1000" dirty="0">
                 <a:solidFill>
-                  <a:srgbClr val="E5E7EB"/>
+                  <a:srgbClr val="E6F1FF"/>
                 </a:solidFill>
               </a:rPr>
               <a:t>7</a:t>
@@ -6921,7 +6921,7 @@
     <p:bg>
       <p:bgPr>
         <a:solidFill>
-          <a:srgbClr val="F5F5F5"/>
+          <a:srgbClr val="FFFFFF"/>
         </a:solidFill>
       </p:bgPr>
     </p:bg>
@@ -6966,7 +6966,7 @@
             <a:r>
               <a:rPr lang="en-US" sz="4000" b="1" dirty="0">
                 <a:solidFill>
-                  <a:srgbClr val="111111"/>
+                  <a:srgbClr val="0A0E27"/>
                 </a:solidFill>
                 <a:latin typeface="Georgia" pitchFamily="34" charset="0"/>
                 <a:ea typeface="Georgia" pitchFamily="34" charset="-122"/>
@@ -6993,7 +6993,7 @@
             <a:avLst/>
           </a:prstGeom>
           <a:solidFill>
-            <a:srgbClr val="E5E7EB"/>
+            <a:srgbClr val="E6F1FF"/>
           </a:solidFill>
           <a:ln/>
         </p:spPr>
@@ -7025,7 +7025,7 @@
             <a:r>
               <a:rPr lang="en-US" sz="2000" b="1" dirty="0">
                 <a:solidFill>
-                  <a:srgbClr val="111111"/>
+                  <a:srgbClr val="0A0E27"/>
                 </a:solidFill>
               </a:rPr>
               <a:t>Professional Goals</a:t>
@@ -7065,7 +7065,7 @@
             <a:r>
               <a:rPr lang="en-US" sz="1500" dirty="0">
                 <a:solidFill>
-                  <a:srgbClr val="0A0A0A"/>
+                  <a:srgbClr val="050816"/>
                 </a:solidFill>
               </a:rPr>
               <a:t>Earned CISSP certification</a:t>
@@ -7083,7 +7083,7 @@
             <a:r>
               <a:rPr lang="en-US" sz="1500" dirty="0">
                 <a:solidFill>
-                  <a:srgbClr val="0A0A0A"/>
+                  <a:srgbClr val="050816"/>
                 </a:solidFill>
               </a:rPr>
               <a:t>Lead a cybersecurity operations team or SOC</a:t>
@@ -7101,7 +7101,7 @@
             <a:r>
               <a:rPr lang="en-US" sz="1500" dirty="0">
                 <a:solidFill>
-                  <a:srgbClr val="0A0A0A"/>
+                  <a:srgbClr val="050816"/>
                 </a:solidFill>
               </a:rPr>
               <a:t>Deepen cloud security automation &amp; IaC practice</a:t>
@@ -7119,7 +7119,7 @@
             <a:r>
               <a:rPr lang="en-US" sz="1500" dirty="0">
                 <a:solidFill>
-                  <a:srgbClr val="0A0A0A"/>
+                  <a:srgbClr val="050816"/>
                 </a:solidFill>
               </a:rPr>
               <a:t>Mentor women entering cybersecurity via RTC &amp; ISSA</a:t>
@@ -7134,7 +7134,7 @@
             <a:r>
               <a:rPr lang="en-US" sz="1500" dirty="0">
                 <a:solidFill>
-                  <a:srgbClr val="0A0A0A"/>
+                  <a:srgbClr val="050816"/>
                 </a:solidFill>
               </a:rPr>
               <a:t>Contribute to enterprise zero-trust architecture</a:t>
@@ -7158,7 +7158,7 @@
             <a:avLst/>
           </a:prstGeom>
           <a:solidFill>
-            <a:srgbClr val="111111"/>
+            <a:srgbClr val="0A0E27"/>
           </a:solidFill>
           <a:ln/>
         </p:spPr>
@@ -7178,7 +7178,7 @@
             <a:avLst/>
           </a:prstGeom>
           <a:solidFill>
-            <a:srgbClr val="D4AF37"/>
+            <a:srgbClr val="00F0FF"/>
           </a:solidFill>
           <a:ln/>
         </p:spPr>
@@ -7210,7 +7210,7 @@
             <a:r>
               <a:rPr lang="en-US" sz="2400" b="1" dirty="0">
                 <a:solidFill>
-                  <a:srgbClr val="F5F5F5"/>
+                  <a:srgbClr val="FFFFFF"/>
                 </a:solidFill>
                 <a:latin typeface="Georgia" pitchFamily="34" charset="0"/>
                 <a:ea typeface="Georgia" pitchFamily="34" charset="-122"/>
@@ -7252,7 +7252,7 @@
             <a:r>
               <a:rPr lang="en-US" sz="1800" b="1" dirty="0">
                 <a:solidFill>
-                  <a:srgbClr val="D4AF37"/>
+                  <a:srgbClr val="00F0FF"/>
                 </a:solidFill>
               </a:rPr>
               <a:t>Tracey Scott</a:t>
@@ -7269,7 +7269,7 @@
             <a:r>
               <a:rPr lang="en-US" sz="1400" i="1" dirty="0">
                 <a:solidFill>
-                  <a:srgbClr val="E5E7EB"/>
+                  <a:srgbClr val="E6F1FF"/>
                 </a:solidFill>
               </a:rPr>
               <a:t>IT Operations Manager &amp; Business Analyst</a:t>
@@ -7286,7 +7286,7 @@
             <a:r>
               <a:rPr lang="en-US" sz="1400" dirty="0">
                 <a:solidFill>
-                  <a:srgbClr val="F5F5F5"/>
+                  <a:srgbClr val="FFFFFF"/>
                 </a:solidFill>
               </a:rPr>
               <a:t>Greenville, SC</a:t>
@@ -7303,7 +7303,7 @@
             <a:r>
               <a:rPr lang="en-US" sz="1400" dirty="0">
                 <a:solidFill>
-                  <a:srgbClr val="F5F5F5"/>
+                  <a:srgbClr val="FFFFFF"/>
                 </a:solidFill>
               </a:rPr>
               <a:t>(864) 775-2929</a:t>
@@ -7320,7 +7320,7 @@
             <a:r>
               <a:rPr lang="en-US" sz="1400" dirty="0">
                 <a:solidFill>
-                  <a:srgbClr val="F5F5F5"/>
+                  <a:srgbClr val="FFFFFF"/>
                 </a:solidFill>
               </a:rPr>
               <a:t>traceysscott82@gmail.com</a:t>
@@ -7337,7 +7337,7 @@
             <a:r>
               <a:rPr lang="en-US" sz="1400" dirty="0">
                 <a:solidFill>
-                  <a:srgbClr val="F5F5F5"/>
+                  <a:srgbClr val="FFFFFF"/>
                 </a:solidFill>
               </a:rPr>
               <a:t>linkedin.com/in/traceysscott</a:t>
@@ -7351,7 +7351,7 @@
             <a:r>
               <a:rPr lang="en-US" sz="1400" b="1" dirty="0">
                 <a:solidFill>
-                  <a:srgbClr val="D4AF37"/>
+                  <a:srgbClr val="00F0FF"/>
                 </a:solidFill>
               </a:rPr>
               <a:t>traceytheanalyst.github.io</a:t>
@@ -7375,7 +7375,7 @@
             <a:avLst/>
           </a:prstGeom>
           <a:solidFill>
-            <a:srgbClr val="111111"/>
+            <a:srgbClr val="0A0E27"/>
           </a:solidFill>
           <a:ln/>
         </p:spPr>
@@ -7407,7 +7407,7 @@
             <a:r>
               <a:rPr lang="en-US" sz="1000" dirty="0">
                 <a:solidFill>
-                  <a:srgbClr val="E5E7EB"/>
+                  <a:srgbClr val="E6F1FF"/>
                 </a:solidFill>
               </a:rPr>
               <a:t>Tracey Scott  |  Cybersecurity • Cloud • SOC  |  traceysscott82@gmail.com</a:t>
@@ -7443,7 +7443,7 @@
             <a:r>
               <a:rPr lang="en-US" sz="1000" dirty="0">
                 <a:solidFill>
-                  <a:srgbClr val="E5E7EB"/>
+                  <a:srgbClr val="E6F1FF"/>
                 </a:solidFill>
               </a:rPr>
               <a:t>8</a:t>

</xml_diff>

<commit_message>
Reduce Professional Goals to two bullets
</commit_message>
<xml_diff>
--- a/Tracey-Scott-Portfolio.pptx
+++ b/Tracey-Scott-Portfolio.pptx
@@ -7057,7 +7057,7 @@
           <a:p>
             <a:pPr marL="342900" indent="-342900">
               <a:spcAft>
-                <a:spcPts val="800"/>
+                <a:spcPts val="1400"/>
               </a:spcAft>
               <a:buSzPct val="100000"/>
               <a:buChar char="•"/>
@@ -7074,9 +7074,6 @@
           </a:p>
           <a:p>
             <a:pPr marL="342900" indent="-342900">
-              <a:spcAft>
-                <a:spcPts val="800"/>
-              </a:spcAft>
               <a:buSzPct val="100000"/>
               <a:buChar char="•"/>
             </a:pPr>
@@ -7086,58 +7083,7 @@
                   <a:srgbClr val="050816"/>
                 </a:solidFill>
               </a:rPr>
-              <a:t>Lead a cybersecurity operations team or SOC</a:t>
-            </a:r>
-            <a:endParaRPr lang="en-US" sz="1500" dirty="0"/>
-          </a:p>
-          <a:p>
-            <a:pPr marL="342900" indent="-342900">
-              <a:spcAft>
-                <a:spcPts val="800"/>
-              </a:spcAft>
-              <a:buSzPct val="100000"/>
-              <a:buChar char="•"/>
-            </a:pPr>
-            <a:r>
-              <a:rPr lang="en-US" sz="1500" dirty="0">
-                <a:solidFill>
-                  <a:srgbClr val="050816"/>
-                </a:solidFill>
-              </a:rPr>
-              <a:t>Deepen cloud security automation &amp; IaC practice</a:t>
-            </a:r>
-            <a:endParaRPr lang="en-US" sz="1500" dirty="0"/>
-          </a:p>
-          <a:p>
-            <a:pPr marL="342900" indent="-342900">
-              <a:spcAft>
-                <a:spcPts val="800"/>
-              </a:spcAft>
-              <a:buSzPct val="100000"/>
-              <a:buChar char="•"/>
-            </a:pPr>
-            <a:r>
-              <a:rPr lang="en-US" sz="1500" dirty="0">
-                <a:solidFill>
-                  <a:srgbClr val="050816"/>
-                </a:solidFill>
-              </a:rPr>
               <a:t>Mentor Women entering cybersecurity via RTC &amp; ISSA</a:t>
-            </a:r>
-            <a:endParaRPr lang="en-US" sz="1500" dirty="0"/>
-          </a:p>
-          <a:p>
-            <a:pPr marL="342900" indent="-342900">
-              <a:buSzPct val="100000"/>
-              <a:buChar char="•"/>
-            </a:pPr>
-            <a:r>
-              <a:rPr lang="en-US" sz="1500" dirty="0">
-                <a:solidFill>
-                  <a:srgbClr val="050816"/>
-                </a:solidFill>
-              </a:rPr>
-              <a:t>Contribute to enterprise zero-trust architecture</a:t>
             </a:r>
             <a:endParaRPr lang="en-US" sz="1500" dirty="0"/>
           </a:p>

</xml_diff>